<commit_message>
feat: otimiza inferencia, corrige dados da apresentacao e adiciona equipe
- Otimiza Predictor.predict: filtro de candidatos com set (O(1)) e
  encode em lote via transform unico, reduzindo a latencia do
  /recommend de ~4.3s para menos de 0.5s com modelo treinado.
- Corrige o roteiro do video (dataset MovieLens: ~100 mil avaliacoes em
  vez de "milhoes") e inclui as metricas reais de teste no Resultado.
- Atualiza a apresentacao PPTX: dataset correto, metricas reais no card
  de avaliacao e bloco "Equipe" no slide de capa com os integrantes.

Co-authored-by: Cursor <cursoragent@cursor.com>
</commit_message>
<xml_diff>
--- a/apresentacao/apresentacao_STAR.pptx
+++ b/apresentacao/apresentacao_STAR.pptx
@@ -3197,8 +3197,8 @@
         </p:nvSpPr>
         <p:spPr>
           <a:xfrm>
-            <a:off x="760000" y="408752"/>
-            <a:ext cx="10000000" cy="500000"/>
+            <a:off x="760000" y="760000"/>
+            <a:ext cx="10000000" cy="373115"/>
           </a:xfrm>
           <a:prstGeom prst="rect">
             <a:avLst/>
@@ -3211,7 +3211,7 @@
           </a:bodyPr>
           <a:lstStyle/>
           <a:p>
-            <a:pPr algn="l">
+            <a:pPr>
               <a:lnSpc>
                 <a:spcPct val="110000"/>
               </a:lnSpc>
@@ -3236,8 +3236,8 @@
         </p:nvSpPr>
         <p:spPr>
           <a:xfrm>
-            <a:off x="740000" y="908752"/>
-            <a:ext cx="10500000" cy="1700000"/>
+            <a:off x="740000" y="1220000"/>
+            <a:ext cx="10500000" cy="1550000"/>
           </a:xfrm>
           <a:prstGeom prst="rect">
             <a:avLst/>
@@ -3250,36 +3250,66 @@
           </a:bodyPr>
           <a:lstStyle/>
           <a:p>
-            <a:pPr algn="l">
+            <a:pPr>
               <a:lnSpc>
                 <a:spcPct val="100000"/>
               </a:lnSpc>
             </a:pPr>
             <a:r>
-              <a:rPr sz="5200" b="1">
+              <a:rPr sz="4600" b="1" dirty="0">
                 <a:solidFill>
                   <a:srgbClr val="F2F5FF"/>
                 </a:solidFill>
                 <a:latin typeface="Segoe UI"/>
               </a:rPr>
-              <a:t>Sistema de Recomendação</a:t>
-            </a:r>
-          </a:p>
-          <a:p>
-            <a:pPr algn="l">
+              <a:t>Sistema de </a:t>
+            </a:r>
+            <a:r>
+              <a:rPr sz="4600" b="1" dirty="0" err="1">
+                <a:solidFill>
+                  <a:srgbClr val="F2F5FF"/>
+                </a:solidFill>
+                <a:latin typeface="Segoe UI"/>
+              </a:rPr>
+              <a:t>Recomendação</a:t>
+            </a:r>
+            <a:endParaRPr sz="4600" b="1" dirty="0">
+              <a:solidFill>
+                <a:srgbClr val="F2F5FF"/>
+              </a:solidFill>
+              <a:latin typeface="Segoe UI"/>
+            </a:endParaRPr>
+          </a:p>
+          <a:p>
+            <a:pPr>
               <a:lnSpc>
                 <a:spcPct val="100000"/>
               </a:lnSpc>
             </a:pPr>
             <a:r>
-              <a:rPr sz="5200" b="1">
+              <a:rPr sz="4600" b="1" dirty="0">
                 <a:solidFill>
                   <a:srgbClr val="F2F5FF"/>
                 </a:solidFill>
                 <a:latin typeface="Segoe UI"/>
               </a:rPr>
-              <a:t>de Filmes</a:t>
-            </a:r>
+              <a:t>de </a:t>
+            </a:r>
+            <a:r>
+              <a:rPr sz="4600" b="1" dirty="0" err="1">
+                <a:solidFill>
+                  <a:srgbClr val="F2F5FF"/>
+                </a:solidFill>
+                <a:latin typeface="Segoe UI"/>
+              </a:rPr>
+              <a:t>Filmes</a:t>
+            </a:r>
+            <a:endParaRPr sz="4600" b="1" dirty="0">
+              <a:solidFill>
+                <a:srgbClr val="F2F5FF"/>
+              </a:solidFill>
+              <a:latin typeface="Segoe UI"/>
+            </a:endParaRPr>
           </a:p>
         </p:txBody>
       </p:sp>
@@ -3291,8 +3321,8 @@
         </p:nvSpPr>
         <p:spPr>
           <a:xfrm>
-            <a:off x="760000" y="2808752"/>
-            <a:ext cx="10000000" cy="600000"/>
+            <a:off x="760000" y="2820000"/>
+            <a:ext cx="10000000" cy="373115"/>
           </a:xfrm>
           <a:prstGeom prst="rect">
             <a:avLst/>
@@ -3305,20 +3335,71 @@
           </a:bodyPr>
           <a:lstStyle/>
           <a:p>
-            <a:pPr algn="l">
+            <a:pPr>
               <a:lnSpc>
                 <a:spcPct val="110000"/>
               </a:lnSpc>
             </a:pPr>
             <a:r>
-              <a:rPr sz="2000" b="0">
-                <a:solidFill>
-                  <a:srgbClr val="A8B3D1"/>
-                </a:solidFill>
-                <a:latin typeface="Segoe UI"/>
-              </a:rPr>
-              <a:t>Do dado bruto do MovieLens a uma API REST de produção</a:t>
-            </a:r>
+              <a:rPr sz="1800" b="0" dirty="0">
+                <a:solidFill>
+                  <a:srgbClr val="A8B3D1"/>
+                </a:solidFill>
+                <a:latin typeface="Segoe UI"/>
+              </a:rPr>
+              <a:t>Do dado </a:t>
+            </a:r>
+            <a:r>
+              <a:rPr sz="1800" b="0" dirty="0" err="1">
+                <a:solidFill>
+                  <a:srgbClr val="A8B3D1"/>
+                </a:solidFill>
+                <a:latin typeface="Segoe UI"/>
+              </a:rPr>
+              <a:t>bruto</a:t>
+            </a:r>
+            <a:r>
+              <a:rPr sz="1800" b="0" dirty="0">
+                <a:solidFill>
+                  <a:srgbClr val="A8B3D1"/>
+                </a:solidFill>
+                <a:latin typeface="Segoe UI"/>
+              </a:rPr>
+              <a:t> do MovieLens a </a:t>
+            </a:r>
+            <a:r>
+              <a:rPr sz="1800" b="0" dirty="0" err="1">
+                <a:solidFill>
+                  <a:srgbClr val="A8B3D1"/>
+                </a:solidFill>
+                <a:latin typeface="Segoe UI"/>
+              </a:rPr>
+              <a:t>uma</a:t>
+            </a:r>
+            <a:r>
+              <a:rPr sz="1800" b="0" dirty="0">
+                <a:solidFill>
+                  <a:srgbClr val="A8B3D1"/>
+                </a:solidFill>
+                <a:latin typeface="Segoe UI"/>
+              </a:rPr>
+              <a:t> API REST de </a:t>
+            </a:r>
+            <a:r>
+              <a:rPr sz="1800" b="0" dirty="0" err="1">
+                <a:solidFill>
+                  <a:srgbClr val="A8B3D1"/>
+                </a:solidFill>
+                <a:latin typeface="Segoe UI"/>
+              </a:rPr>
+              <a:t>produção</a:t>
+            </a:r>
+            <a:endParaRPr sz="1800" b="0" dirty="0">
+              <a:solidFill>
+                <a:srgbClr val="A8B3D1"/>
+              </a:solidFill>
+              <a:latin typeface="Segoe UI"/>
+            </a:endParaRPr>
           </a:p>
         </p:txBody>
       </p:sp>
@@ -3330,8 +3411,8 @@
         </p:nvSpPr>
         <p:spPr>
           <a:xfrm>
-            <a:off x="760000" y="3658752"/>
-            <a:ext cx="10600000" cy="1000000"/>
+            <a:off x="760000" y="3450000"/>
+            <a:ext cx="10600000" cy="884256"/>
           </a:xfrm>
           <a:prstGeom prst="roundRect">
             <a:avLst/>
@@ -3362,9 +3443,8 @@
           <a:bodyPr wrap="square" lIns="220000" tIns="200000" rIns="220000" bIns="160000" rtlCol="0" anchor="t"/>
           <a:lstStyle/>
           <a:p>
-            <a:pPr algn="ctr"/>
-            <a:r>
-              <a:rPr sz="1700" b="1">
+            <a:r>
+              <a:rPr sz="1700" b="1" dirty="0">
                 <a:solidFill>
                   <a:srgbClr val="4F9CFF"/>
                 </a:solidFill>
@@ -3383,14 +3463,101 @@
               </a:spcBef>
             </a:pPr>
             <a:r>
-              <a:rPr sz="1250">
-                <a:solidFill>
-                  <a:srgbClr val="A8B3D1"/>
-                </a:solidFill>
-                <a:latin typeface="Segoe UI"/>
-              </a:rPr>
-              <a:t>Python · PyTorch · FastAPI · MLflow · DVC · uv · Docker · pytest</a:t>
-            </a:r>
+              <a:rPr sz="1250" dirty="0">
+                <a:solidFill>
+                  <a:srgbClr val="A8B3D1"/>
+                </a:solidFill>
+                <a:latin typeface="Segoe UI"/>
+              </a:rPr>
+              <a:t>Python · </a:t>
+            </a:r>
+            <a:r>
+              <a:rPr sz="1250" dirty="0" err="1">
+                <a:solidFill>
+                  <a:srgbClr val="A8B3D1"/>
+                </a:solidFill>
+                <a:latin typeface="Segoe UI"/>
+              </a:rPr>
+              <a:t>PyTorch</a:t>
+            </a:r>
+            <a:r>
+              <a:rPr sz="1250" dirty="0">
+                <a:solidFill>
+                  <a:srgbClr val="A8B3D1"/>
+                </a:solidFill>
+                <a:latin typeface="Segoe UI"/>
+              </a:rPr>
+              <a:t> · </a:t>
+            </a:r>
+            <a:r>
+              <a:rPr sz="1250" dirty="0" err="1">
+                <a:solidFill>
+                  <a:srgbClr val="A8B3D1"/>
+                </a:solidFill>
+                <a:latin typeface="Segoe UI"/>
+              </a:rPr>
+              <a:t>FastAPI</a:t>
+            </a:r>
+            <a:r>
+              <a:rPr sz="1250" dirty="0">
+                <a:solidFill>
+                  <a:srgbClr val="A8B3D1"/>
+                </a:solidFill>
+                <a:latin typeface="Segoe UI"/>
+              </a:rPr>
+              <a:t> · </a:t>
+            </a:r>
+            <a:r>
+              <a:rPr sz="1250" dirty="0" err="1">
+                <a:solidFill>
+                  <a:srgbClr val="A8B3D1"/>
+                </a:solidFill>
+                <a:latin typeface="Segoe UI"/>
+              </a:rPr>
+              <a:t>MLflow</a:t>
+            </a:r>
+            <a:r>
+              <a:rPr sz="1250" dirty="0">
+                <a:solidFill>
+                  <a:srgbClr val="A8B3D1"/>
+                </a:solidFill>
+                <a:latin typeface="Segoe UI"/>
+              </a:rPr>
+              <a:t> · DVC · </a:t>
+            </a:r>
+            <a:r>
+              <a:rPr sz="1250" dirty="0" err="1">
+                <a:solidFill>
+                  <a:srgbClr val="A8B3D1"/>
+                </a:solidFill>
+                <a:latin typeface="Segoe UI"/>
+              </a:rPr>
+              <a:t>uv</a:t>
+            </a:r>
+            <a:r>
+              <a:rPr sz="1250" dirty="0">
+                <a:solidFill>
+                  <a:srgbClr val="A8B3D1"/>
+                </a:solidFill>
+                <a:latin typeface="Segoe UI"/>
+              </a:rPr>
+              <a:t> · Docker · </a:t>
+            </a:r>
+            <a:r>
+              <a:rPr sz="1250" dirty="0" err="1">
+                <a:solidFill>
+                  <a:srgbClr val="A8B3D1"/>
+                </a:solidFill>
+                <a:latin typeface="Segoe UI"/>
+              </a:rPr>
+              <a:t>pytest</a:t>
+            </a:r>
+            <a:endParaRPr sz="1250" dirty="0">
+              <a:solidFill>
+                <a:srgbClr val="A8B3D1"/>
+              </a:solidFill>
+              <a:latin typeface="Segoe UI"/>
+            </a:endParaRPr>
           </a:p>
         </p:txBody>
       </p:sp>
@@ -3402,8 +3569,8 @@
         </p:nvSpPr>
         <p:spPr>
           <a:xfrm>
-            <a:off x="760000" y="4908752"/>
-            <a:ext cx="10000000" cy="1732654"/>
+            <a:off x="760000" y="4491440"/>
+            <a:ext cx="10000000" cy="295145"/>
           </a:xfrm>
           <a:prstGeom prst="rect">
             <a:avLst/>
@@ -3416,13 +3583,13 @@
           </a:bodyPr>
           <a:lstStyle/>
           <a:p>
-            <a:pPr algn="l">
+            <a:pPr>
               <a:lnSpc>
                 <a:spcPct val="110000"/>
               </a:lnSpc>
             </a:pPr>
             <a:r>
-              <a:rPr sz="1400" b="1" dirty="0" err="1">
+              <a:rPr sz="1300" b="1" dirty="0" err="1">
                 <a:solidFill>
                   <a:srgbClr val="4F9CFF"/>
                 </a:solidFill>
@@ -3431,7 +3598,7 @@
               <a:t>Apresentação</a:t>
             </a:r>
             <a:r>
-              <a:rPr sz="1400" b="1" dirty="0">
+              <a:rPr sz="1300" b="1" dirty="0">
                 <a:solidFill>
                   <a:srgbClr val="4F9CFF"/>
                 </a:solidFill>
@@ -3440,7 +3607,7 @@
               <a:t> no </a:t>
             </a:r>
             <a:r>
-              <a:rPr sz="1400" b="1" dirty="0" err="1">
+              <a:rPr sz="1300" b="1" dirty="0" err="1">
                 <a:solidFill>
                   <a:srgbClr val="4F9CFF"/>
                 </a:solidFill>
@@ -3449,7 +3616,7 @@
               <a:t>modelo</a:t>
             </a:r>
             <a:r>
-              <a:rPr sz="1400" b="1" dirty="0">
+              <a:rPr sz="1300" b="1" dirty="0">
                 <a:solidFill>
                   <a:srgbClr val="4F9CFF"/>
                 </a:solidFill>
@@ -3458,7 +3625,7 @@
               <a:t> STAR — </a:t>
             </a:r>
             <a:r>
-              <a:rPr sz="1400" b="1" dirty="0" err="1">
+              <a:rPr sz="1300" b="1" dirty="0" err="1">
                 <a:solidFill>
                   <a:srgbClr val="4F9CFF"/>
                 </a:solidFill>
@@ -3467,7 +3634,7 @@
               <a:t>Situação</a:t>
             </a:r>
             <a:r>
-              <a:rPr sz="1400" b="1" dirty="0">
+              <a:rPr sz="1300" b="1" dirty="0">
                 <a:solidFill>
                   <a:srgbClr val="4F9CFF"/>
                 </a:solidFill>
@@ -3476,7 +3643,7 @@
               <a:t> · </a:t>
             </a:r>
             <a:r>
-              <a:rPr sz="1400" b="1" dirty="0" err="1">
+              <a:rPr sz="1300" b="1" dirty="0" err="1">
                 <a:solidFill>
                   <a:srgbClr val="4F9CFF"/>
                 </a:solidFill>
@@ -3485,7 +3652,7 @@
               <a:t>Tarefa</a:t>
             </a:r>
             <a:r>
-              <a:rPr sz="1400" b="1" dirty="0">
+              <a:rPr sz="1300" b="1" dirty="0">
                 <a:solidFill>
                   <a:srgbClr val="4F9CFF"/>
                 </a:solidFill>
@@ -3494,7 +3661,7 @@
               <a:t> · </a:t>
             </a:r>
             <a:r>
-              <a:rPr sz="1400" b="1" dirty="0" err="1">
+              <a:rPr sz="1300" b="1" dirty="0" err="1">
                 <a:solidFill>
                   <a:srgbClr val="4F9CFF"/>
                 </a:solidFill>
@@ -3503,7 +3670,7 @@
               <a:t>Ação</a:t>
             </a:r>
             <a:r>
-              <a:rPr sz="1400" b="1" dirty="0">
+              <a:rPr sz="1300" b="1" dirty="0">
                 <a:solidFill>
                   <a:srgbClr val="4F9CFF"/>
                 </a:solidFill>
@@ -3512,7 +3679,7 @@
               <a:t> · </a:t>
             </a:r>
             <a:r>
-              <a:rPr sz="1400" b="1" dirty="0" err="1">
+              <a:rPr sz="1300" b="1" dirty="0" err="1">
                 <a:solidFill>
                   <a:srgbClr val="4F9CFF"/>
                 </a:solidFill>
@@ -3520,141 +3687,140 @@
               </a:rPr>
               <a:t>Resultado</a:t>
             </a:r>
-            <a:endParaRPr lang="pt-BR" sz="1400" b="1" dirty="0">
+            <a:endParaRPr sz="1300" b="1" dirty="0">
               <a:solidFill>
                 <a:srgbClr val="4F9CFF"/>
               </a:solidFill>
               <a:latin typeface="Segoe UI"/>
             </a:endParaRPr>
           </a:p>
+        </p:txBody>
+      </p:sp>
+      <p:sp>
+        <p:nvSpPr>
+          <p:cNvPr id="9" name="Rounded Rectangle 8"/>
+          <p:cNvSpPr/>
+          <p:nvPr/>
+        </p:nvSpPr>
+        <p:spPr>
+          <a:xfrm>
+            <a:off x="760000" y="4980000"/>
+            <a:ext cx="10600000" cy="1685976"/>
+          </a:xfrm>
+          <a:prstGeom prst="roundRect">
+            <a:avLst/>
+          </a:prstGeom>
+          <a:solidFill>
+            <a:srgbClr val="162140"/>
+          </a:solidFill>
+          <a:ln>
+            <a:noFill/>
+          </a:ln>
+          <a:effectLst/>
+        </p:spPr>
+        <p:style>
+          <a:lnRef idx="1">
+            <a:schemeClr val="accent1"/>
+          </a:lnRef>
+          <a:fillRef idx="3">
+            <a:schemeClr val="accent1"/>
+          </a:fillRef>
+          <a:effectRef idx="2">
+            <a:schemeClr val="accent1"/>
+          </a:effectRef>
+          <a:fontRef idx="minor">
+            <a:schemeClr val="lt1"/>
+          </a:fontRef>
+        </p:style>
+        <p:txBody>
+          <a:bodyPr wrap="square" lIns="220000" tIns="200000" rIns="220000" bIns="160000" rtlCol="0" anchor="t"/>
+          <a:lstStyle/>
+          <a:p>
+            <a:r>
+              <a:rPr sz="1700" b="1" dirty="0">
+                <a:solidFill>
+                  <a:srgbClr val="2EE6B6"/>
+                </a:solidFill>
+                <a:latin typeface="Segoe UI"/>
+              </a:rPr>
+              <a:t>Equipe</a:t>
+            </a:r>
+          </a:p>
           <a:p>
             <a:pPr>
               <a:lnSpc>
-                <a:spcPct val="110000"/>
+                <a:spcPct val="108000"/>
               </a:lnSpc>
-              <a:defRPr sz="1800">
-                <a:solidFill>
-                  <a:srgbClr val="B4C8E6"/>
-                </a:solidFill>
-              </a:defRPr>
+              <a:spcBef>
+                <a:spcPts val="500"/>
+              </a:spcBef>
             </a:pPr>
-            <a:endParaRPr lang="pt-BR" sz="1400" b="1" dirty="0">
-              <a:solidFill>
-                <a:srgbClr val="4F9CFF"/>
-              </a:solidFill>
-              <a:latin typeface="Segoe UI"/>
-            </a:endParaRPr>
+            <a:r>
+              <a:rPr sz="1250" dirty="0">
+                <a:solidFill>
+                  <a:srgbClr val="A8B3D1"/>
+                </a:solidFill>
+                <a:latin typeface="Segoe UI"/>
+              </a:rPr>
+              <a:t>Alexis Ferreira Duarte – RM371356</a:t>
+            </a:r>
           </a:p>
           <a:p>
             <a:pPr>
               <a:lnSpc>
-                <a:spcPct val="110000"/>
+                <a:spcPct val="108000"/>
               </a:lnSpc>
-              <a:defRPr sz="1800">
-                <a:solidFill>
-                  <a:srgbClr val="B4C8E6"/>
-                </a:solidFill>
-              </a:defRPr>
+              <a:spcBef>
+                <a:spcPts val="500"/>
+              </a:spcBef>
             </a:pPr>
             <a:r>
-              <a:rPr lang="pt-BR" sz="1400" b="1" dirty="0">
-                <a:solidFill>
-                  <a:srgbClr val="4F9CFF"/>
-                </a:solidFill>
-                <a:latin typeface="Segoe UI"/>
-              </a:rPr>
-              <a:t>Equipe:</a:t>
+              <a:rPr sz="1250" dirty="0">
+                <a:solidFill>
+                  <a:srgbClr val="A8B3D1"/>
+                </a:solidFill>
+                <a:latin typeface="Segoe UI"/>
+              </a:rPr>
+              <a:t>George Ricardo dos Santos – RM374213</a:t>
             </a:r>
           </a:p>
           <a:p>
             <a:pPr>
               <a:lnSpc>
-                <a:spcPct val="110000"/>
+                <a:spcPct val="108000"/>
               </a:lnSpc>
-              <a:defRPr sz="1800">
-                <a:solidFill>
-                  <a:srgbClr val="B4C8E6"/>
-                </a:solidFill>
-              </a:defRPr>
+              <a:spcBef>
+                <a:spcPts val="500"/>
+              </a:spcBef>
             </a:pPr>
             <a:r>
-              <a:rPr lang="pt-BR" sz="1400" b="1" dirty="0">
-                <a:solidFill>
-                  <a:srgbClr val="4F9CFF"/>
-                </a:solidFill>
-                <a:latin typeface="Segoe UI"/>
-              </a:rPr>
-              <a:t>Alexis Ferreira Duarte – RM371356</a:t>
+              <a:rPr sz="1250" dirty="0">
+                <a:solidFill>
+                  <a:srgbClr val="A8B3D1"/>
+                </a:solidFill>
+                <a:latin typeface="Segoe UI"/>
+              </a:rPr>
+              <a:t>Leandro de Souza Pignataro – RM373704</a:t>
             </a:r>
           </a:p>
           <a:p>
             <a:pPr>
               <a:lnSpc>
-                <a:spcPct val="110000"/>
+                <a:spcPct val="108000"/>
               </a:lnSpc>
-              <a:defRPr sz="1800">
-                <a:solidFill>
-                  <a:srgbClr val="B4C8E6"/>
-                </a:solidFill>
-              </a:defRPr>
+              <a:spcBef>
+                <a:spcPts val="500"/>
+              </a:spcBef>
             </a:pPr>
             <a:r>
-              <a:rPr lang="pt-BR" sz="1400" b="1" dirty="0">
-                <a:solidFill>
-                  <a:srgbClr val="4F9CFF"/>
-                </a:solidFill>
-                <a:latin typeface="Segoe UI"/>
-              </a:rPr>
-              <a:t>George Ricardo dos Santos – RM374213</a:t>
-            </a:r>
-          </a:p>
-          <a:p>
-            <a:pPr>
-              <a:lnSpc>
-                <a:spcPct val="110000"/>
-              </a:lnSpc>
-              <a:defRPr sz="1800">
-                <a:solidFill>
-                  <a:srgbClr val="B4C8E6"/>
-                </a:solidFill>
-              </a:defRPr>
-            </a:pPr>
-            <a:r>
-              <a:rPr lang="pt-BR" sz="1400" b="1" dirty="0">
-                <a:solidFill>
-                  <a:srgbClr val="4F9CFF"/>
-                </a:solidFill>
-                <a:latin typeface="Segoe UI"/>
-              </a:rPr>
-              <a:t>Leandro de Souza Pignataro – RM373704</a:t>
-            </a:r>
-          </a:p>
-          <a:p>
-            <a:pPr>
-              <a:lnSpc>
-                <a:spcPct val="110000"/>
-              </a:lnSpc>
-              <a:defRPr sz="1800">
-                <a:solidFill>
-                  <a:srgbClr val="B4C8E6"/>
-                </a:solidFill>
-              </a:defRPr>
-            </a:pPr>
-            <a:r>
-              <a:rPr lang="pt-BR" sz="1400" b="1" dirty="0">
-                <a:solidFill>
-                  <a:srgbClr val="4F9CFF"/>
+              <a:rPr sz="1250" dirty="0">
+                <a:solidFill>
+                  <a:srgbClr val="A8B3D1"/>
                 </a:solidFill>
                 <a:latin typeface="Segoe UI"/>
               </a:rPr>
               <a:t>Nicolas de Araújo Gomes – RM370990</a:t>
             </a:r>
-            <a:endParaRPr sz="1400" b="1" dirty="0">
-              <a:solidFill>
-                <a:srgbClr val="4F9CFF"/>
-              </a:solidFill>
-              <a:latin typeface="Segoe UI"/>
-            </a:endParaRPr>
           </a:p>
         </p:txBody>
       </p:sp>
@@ -3977,15 +4143,23 @@
           <a:bodyPr wrap="square" lIns="220000" tIns="200000" rIns="220000" bIns="160000" rtlCol="0" anchor="t"/>
           <a:lstStyle/>
           <a:p>
-            <a:pPr algn="ctr"/>
-            <a:r>
-              <a:rPr sz="1700" b="1">
+            <a:r>
+              <a:rPr sz="1700" b="1" dirty="0" err="1">
                 <a:solidFill>
                   <a:srgbClr val="2EE6B6"/>
                 </a:solidFill>
                 <a:latin typeface="Segoe UI"/>
               </a:rPr>
-              <a:t>Obrigado!</a:t>
+              <a:t>Obrigado</a:t>
+            </a:r>
+            <a:r>
+              <a:rPr sz="1700" b="1" dirty="0">
+                <a:solidFill>
+                  <a:srgbClr val="2EE6B6"/>
+                </a:solidFill>
+                <a:latin typeface="Segoe UI"/>
+              </a:rPr>
+              <a:t>!</a:t>
             </a:r>
           </a:p>
           <a:p>
@@ -3998,13 +4172,49 @@
               </a:spcBef>
             </a:pPr>
             <a:r>
-              <a:rPr sz="1250">
-                <a:solidFill>
-                  <a:srgbClr val="A8B3D1"/>
-                </a:solidFill>
-                <a:latin typeface="Segoe UI"/>
-              </a:rPr>
-              <a:t>Sistema de Recomendação de Filmes — Tech Challenge FIAP.</a:t>
+              <a:rPr sz="1250" dirty="0">
+                <a:solidFill>
+                  <a:srgbClr val="A8B3D1"/>
+                </a:solidFill>
+                <a:latin typeface="Segoe UI"/>
+              </a:rPr>
+              <a:t>Sistema de </a:t>
+            </a:r>
+            <a:r>
+              <a:rPr sz="1250" dirty="0" err="1">
+                <a:solidFill>
+                  <a:srgbClr val="A8B3D1"/>
+                </a:solidFill>
+                <a:latin typeface="Segoe UI"/>
+              </a:rPr>
+              <a:t>Recomendação</a:t>
+            </a:r>
+            <a:r>
+              <a:rPr sz="1250" dirty="0">
+                <a:solidFill>
+                  <a:srgbClr val="A8B3D1"/>
+                </a:solidFill>
+                <a:latin typeface="Segoe UI"/>
+              </a:rPr>
+              <a:t> de </a:t>
+            </a:r>
+            <a:r>
+              <a:rPr sz="1250" dirty="0" err="1">
+                <a:solidFill>
+                  <a:srgbClr val="A8B3D1"/>
+                </a:solidFill>
+                <a:latin typeface="Segoe UI"/>
+              </a:rPr>
+              <a:t>Filmes</a:t>
+            </a:r>
+            <a:r>
+              <a:rPr sz="1250" dirty="0">
+                <a:solidFill>
+                  <a:srgbClr val="A8B3D1"/>
+                </a:solidFill>
+                <a:latin typeface="Segoe UI"/>
+              </a:rPr>
+              <a:t> — Tech Challenge FIAP.</a:t>
             </a:r>
           </a:p>
           <a:p>
@@ -4017,13 +4227,40 @@
               </a:spcBef>
             </a:pPr>
             <a:r>
-              <a:rPr sz="1250">
-                <a:solidFill>
-                  <a:srgbClr val="A8B3D1"/>
-                </a:solidFill>
-                <a:latin typeface="Segoe UI"/>
-              </a:rPr>
-              <a:t>Demonstração ao vivo: http://localhost:8000/docs</a:t>
+              <a:rPr sz="1250" dirty="0" err="1">
+                <a:solidFill>
+                  <a:srgbClr val="A8B3D1"/>
+                </a:solidFill>
+                <a:latin typeface="Segoe UI"/>
+              </a:rPr>
+              <a:t>Demonstração</a:t>
+            </a:r>
+            <a:r>
+              <a:rPr sz="1250" dirty="0">
+                <a:solidFill>
+                  <a:srgbClr val="A8B3D1"/>
+                </a:solidFill>
+                <a:latin typeface="Segoe UI"/>
+              </a:rPr>
+              <a:t> </a:t>
+            </a:r>
+            <a:r>
+              <a:rPr sz="1250" dirty="0" err="1">
+                <a:solidFill>
+                  <a:srgbClr val="A8B3D1"/>
+                </a:solidFill>
+                <a:latin typeface="Segoe UI"/>
+              </a:rPr>
+              <a:t>ao</a:t>
+            </a:r>
+            <a:r>
+              <a:rPr sz="1250" dirty="0">
+                <a:solidFill>
+                  <a:srgbClr val="A8B3D1"/>
+                </a:solidFill>
+                <a:latin typeface="Segoe UI"/>
+              </a:rPr>
+              <a:t> vivo: http://localhost:8000/docs</a:t>
             </a:r>
           </a:p>
         </p:txBody>
@@ -4319,7 +4556,7 @@
                 </a:solidFill>
                 <a:latin typeface="Segoe UI"/>
               </a:rPr>
-              <a:t>▸  Dataset MovieLens: milhões de avaliações de filmes feitas por usuários reais.</a:t>
+              <a:t>▸  Dataset MovieLens: mais de 100 mil avaliações de filmes feitas por usuários reais.</a:t>
             </a:r>
           </a:p>
           <a:p>
@@ -4383,9 +4620,8 @@
           <a:bodyPr wrap="square" lIns="220000" tIns="200000" rIns="220000" bIns="160000" rtlCol="0" anchor="t"/>
           <a:lstStyle/>
           <a:p>
-            <a:pPr algn="ctr"/>
-            <a:r>
-              <a:rPr sz="1700" b="1">
+            <a:r>
+              <a:rPr sz="1700" b="1" dirty="0" err="1">
                 <a:solidFill>
                   <a:srgbClr val="4F9CFF"/>
                 </a:solidFill>
@@ -4393,6 +4629,12 @@
               </a:rPr>
               <a:t>Contexto</a:t>
             </a:r>
+            <a:endParaRPr sz="1700" b="1" dirty="0">
+              <a:solidFill>
+                <a:srgbClr val="4F9CFF"/>
+              </a:solidFill>
+              <a:latin typeface="Segoe UI"/>
+            </a:endParaRPr>
           </a:p>
           <a:p>
             <a:pPr>
@@ -4404,13 +4646,112 @@
               </a:spcBef>
             </a:pPr>
             <a:r>
-              <a:rPr sz="1250">
-                <a:solidFill>
-                  <a:srgbClr val="A8B3D1"/>
-                </a:solidFill>
-                <a:latin typeface="Segoe UI"/>
-              </a:rPr>
-              <a:t>Projeto acadêmico do Tech Challenge FIAP — recomendação de filmes ponta a ponta com Machine Learning.</a:t>
+              <a:rPr sz="1250" dirty="0" err="1">
+                <a:solidFill>
+                  <a:srgbClr val="A8B3D1"/>
+                </a:solidFill>
+                <a:latin typeface="Segoe UI"/>
+              </a:rPr>
+              <a:t>Projeto</a:t>
+            </a:r>
+            <a:r>
+              <a:rPr sz="1250" dirty="0">
+                <a:solidFill>
+                  <a:srgbClr val="A8B3D1"/>
+                </a:solidFill>
+                <a:latin typeface="Segoe UI"/>
+              </a:rPr>
+              <a:t> </a:t>
+            </a:r>
+            <a:r>
+              <a:rPr sz="1250" dirty="0" err="1">
+                <a:solidFill>
+                  <a:srgbClr val="A8B3D1"/>
+                </a:solidFill>
+                <a:latin typeface="Segoe UI"/>
+              </a:rPr>
+              <a:t>acadêmico</a:t>
+            </a:r>
+            <a:r>
+              <a:rPr sz="1250" dirty="0">
+                <a:solidFill>
+                  <a:srgbClr val="A8B3D1"/>
+                </a:solidFill>
+                <a:latin typeface="Segoe UI"/>
+              </a:rPr>
+              <a:t> do Tech Challenge FIAP — </a:t>
+            </a:r>
+            <a:r>
+              <a:rPr sz="1250" dirty="0" err="1">
+                <a:solidFill>
+                  <a:srgbClr val="A8B3D1"/>
+                </a:solidFill>
+                <a:latin typeface="Segoe UI"/>
+              </a:rPr>
+              <a:t>recomendação</a:t>
+            </a:r>
+            <a:r>
+              <a:rPr sz="1250" dirty="0">
+                <a:solidFill>
+                  <a:srgbClr val="A8B3D1"/>
+                </a:solidFill>
+                <a:latin typeface="Segoe UI"/>
+              </a:rPr>
+              <a:t> de </a:t>
+            </a:r>
+            <a:r>
+              <a:rPr sz="1250" dirty="0" err="1">
+                <a:solidFill>
+                  <a:srgbClr val="A8B3D1"/>
+                </a:solidFill>
+                <a:latin typeface="Segoe UI"/>
+              </a:rPr>
+              <a:t>filmes</a:t>
+            </a:r>
+            <a:r>
+              <a:rPr sz="1250" dirty="0">
+                <a:solidFill>
+                  <a:srgbClr val="A8B3D1"/>
+                </a:solidFill>
+                <a:latin typeface="Segoe UI"/>
+              </a:rPr>
+              <a:t> </a:t>
+            </a:r>
+            <a:r>
+              <a:rPr sz="1250" dirty="0" err="1">
+                <a:solidFill>
+                  <a:srgbClr val="A8B3D1"/>
+                </a:solidFill>
+                <a:latin typeface="Segoe UI"/>
+              </a:rPr>
+              <a:t>ponta</a:t>
+            </a:r>
+            <a:r>
+              <a:rPr sz="1250" dirty="0">
+                <a:solidFill>
+                  <a:srgbClr val="A8B3D1"/>
+                </a:solidFill>
+                <a:latin typeface="Segoe UI"/>
+              </a:rPr>
+              <a:t> a </a:t>
+            </a:r>
+            <a:r>
+              <a:rPr sz="1250" dirty="0" err="1">
+                <a:solidFill>
+                  <a:srgbClr val="A8B3D1"/>
+                </a:solidFill>
+                <a:latin typeface="Segoe UI"/>
+              </a:rPr>
+              <a:t>ponta</a:t>
+            </a:r>
+            <a:r>
+              <a:rPr sz="1250" dirty="0">
+                <a:solidFill>
+                  <a:srgbClr val="A8B3D1"/>
+                </a:solidFill>
+                <a:latin typeface="Segoe UI"/>
+              </a:rPr>
+              <a:t> com Machine Learning.</a:t>
             </a:r>
           </a:p>
         </p:txBody>
@@ -4671,16 +5012,30 @@
           <a:bodyPr wrap="square" lIns="220000" tIns="200000" rIns="220000" bIns="160000" rtlCol="0" anchor="t"/>
           <a:lstStyle/>
           <a:p>
-            <a:pPr algn="ctr"/>
-            <a:r>
-              <a:rPr sz="1700" b="1">
+            <a:r>
+              <a:rPr sz="1700" b="1" dirty="0">
                 <a:solidFill>
                   <a:srgbClr val="4F9CFF"/>
                 </a:solidFill>
                 <a:latin typeface="Segoe UI"/>
               </a:rPr>
-              <a:t>1 · Modelar</a:t>
-            </a:r>
+              <a:t>1 · </a:t>
+            </a:r>
+            <a:r>
+              <a:rPr sz="1700" b="1" dirty="0" err="1">
+                <a:solidFill>
+                  <a:srgbClr val="4F9CFF"/>
+                </a:solidFill>
+                <a:latin typeface="Segoe UI"/>
+              </a:rPr>
+              <a:t>Modelar</a:t>
+            </a:r>
+            <a:endParaRPr sz="1700" b="1" dirty="0">
+              <a:solidFill>
+                <a:srgbClr val="4F9CFF"/>
+              </a:solidFill>
+              <a:latin typeface="Segoe UI"/>
+            </a:endParaRPr>
           </a:p>
           <a:p>
             <a:pPr>
@@ -4692,13 +5047,40 @@
               </a:spcBef>
             </a:pPr>
             <a:r>
-              <a:rPr sz="1250">
-                <a:solidFill>
-                  <a:srgbClr val="A8B3D1"/>
-                </a:solidFill>
-                <a:latin typeface="Segoe UI"/>
-              </a:rPr>
-              <a:t>Classificação binária:</a:t>
+              <a:rPr sz="1250" dirty="0" err="1">
+                <a:solidFill>
+                  <a:srgbClr val="A8B3D1"/>
+                </a:solidFill>
+                <a:latin typeface="Segoe UI"/>
+              </a:rPr>
+              <a:t>Classificação</a:t>
+            </a:r>
+            <a:r>
+              <a:rPr sz="1250" dirty="0">
+                <a:solidFill>
+                  <a:srgbClr val="A8B3D1"/>
+                </a:solidFill>
+                <a:latin typeface="Segoe UI"/>
+              </a:rPr>
+              <a:t> </a:t>
+            </a:r>
+            <a:r>
+              <a:rPr sz="1250" dirty="0" err="1">
+                <a:solidFill>
+                  <a:srgbClr val="A8B3D1"/>
+                </a:solidFill>
+                <a:latin typeface="Segoe UI"/>
+              </a:rPr>
+              <a:t>binária</a:t>
+            </a:r>
+            <a:r>
+              <a:rPr sz="1250" dirty="0">
+                <a:solidFill>
+                  <a:srgbClr val="A8B3D1"/>
+                </a:solidFill>
+                <a:latin typeface="Segoe UI"/>
+              </a:rPr>
+              <a:t>:</a:t>
             </a:r>
           </a:p>
           <a:p>
@@ -4711,14 +5093,56 @@
               </a:spcBef>
             </a:pPr>
             <a:r>
-              <a:rPr sz="1250">
-                <a:solidFill>
-                  <a:srgbClr val="A8B3D1"/>
-                </a:solidFill>
-                <a:latin typeface="Segoe UI"/>
-              </a:rPr>
-              <a:t>prever se o usuário daria</a:t>
-            </a:r>
+              <a:rPr sz="1250" dirty="0" err="1">
+                <a:solidFill>
+                  <a:srgbClr val="A8B3D1"/>
+                </a:solidFill>
+                <a:latin typeface="Segoe UI"/>
+              </a:rPr>
+              <a:t>prever</a:t>
+            </a:r>
+            <a:r>
+              <a:rPr sz="1250" dirty="0">
+                <a:solidFill>
+                  <a:srgbClr val="A8B3D1"/>
+                </a:solidFill>
+                <a:latin typeface="Segoe UI"/>
+              </a:rPr>
+              <a:t> se o </a:t>
+            </a:r>
+            <a:r>
+              <a:rPr sz="1250" dirty="0" err="1">
+                <a:solidFill>
+                  <a:srgbClr val="A8B3D1"/>
+                </a:solidFill>
+                <a:latin typeface="Segoe UI"/>
+              </a:rPr>
+              <a:t>usuário</a:t>
+            </a:r>
+            <a:r>
+              <a:rPr sz="1250" dirty="0">
+                <a:solidFill>
+                  <a:srgbClr val="A8B3D1"/>
+                </a:solidFill>
+                <a:latin typeface="Segoe UI"/>
+              </a:rPr>
+              <a:t> </a:t>
+            </a:r>
+            <a:r>
+              <a:rPr sz="1250" dirty="0" err="1">
+                <a:solidFill>
+                  <a:srgbClr val="A8B3D1"/>
+                </a:solidFill>
+                <a:latin typeface="Segoe UI"/>
+              </a:rPr>
+              <a:t>daria</a:t>
+            </a:r>
+            <a:endParaRPr sz="1250" dirty="0">
+              <a:solidFill>
+                <a:srgbClr val="A8B3D1"/>
+              </a:solidFill>
+              <a:latin typeface="Segoe UI"/>
+            </a:endParaRPr>
           </a:p>
           <a:p>
             <a:pPr>
@@ -4730,13 +5154,67 @@
               </a:spcBef>
             </a:pPr>
             <a:r>
-              <a:rPr sz="1250">
-                <a:solidFill>
-                  <a:srgbClr val="A8B3D1"/>
-                </a:solidFill>
-                <a:latin typeface="Segoe UI"/>
-              </a:rPr>
-              <a:t>nota ≥ 4 (gostou / não gostou).</a:t>
+              <a:rPr sz="1250" dirty="0">
+                <a:solidFill>
+                  <a:srgbClr val="A8B3D1"/>
+                </a:solidFill>
+                <a:latin typeface="Segoe UI"/>
+              </a:rPr>
+              <a:t>nota ≥ 4 (</a:t>
+            </a:r>
+            <a:r>
+              <a:rPr sz="1250" dirty="0" err="1">
+                <a:solidFill>
+                  <a:srgbClr val="A8B3D1"/>
+                </a:solidFill>
+                <a:latin typeface="Segoe UI"/>
+              </a:rPr>
+              <a:t>gostou</a:t>
+            </a:r>
+            <a:r>
+              <a:rPr sz="1250" dirty="0">
+                <a:solidFill>
+                  <a:srgbClr val="A8B3D1"/>
+                </a:solidFill>
+                <a:latin typeface="Segoe UI"/>
+              </a:rPr>
+              <a:t> / </a:t>
+            </a:r>
+            <a:r>
+              <a:rPr sz="1250" dirty="0" err="1">
+                <a:solidFill>
+                  <a:srgbClr val="A8B3D1"/>
+                </a:solidFill>
+                <a:latin typeface="Segoe UI"/>
+              </a:rPr>
+              <a:t>não</a:t>
+            </a:r>
+            <a:r>
+              <a:rPr sz="1250" dirty="0">
+                <a:solidFill>
+                  <a:srgbClr val="A8B3D1"/>
+                </a:solidFill>
+                <a:latin typeface="Segoe UI"/>
+              </a:rPr>
+              <a:t> </a:t>
+            </a:r>
+            <a:r>
+              <a:rPr sz="1250" dirty="0" err="1">
+                <a:solidFill>
+                  <a:srgbClr val="A8B3D1"/>
+                </a:solidFill>
+                <a:latin typeface="Segoe UI"/>
+              </a:rPr>
+              <a:t>gostou</a:t>
+            </a:r>
+            <a:r>
+              <a:rPr sz="1250" dirty="0">
+                <a:solidFill>
+                  <a:srgbClr val="A8B3D1"/>
+                </a:solidFill>
+                <a:latin typeface="Segoe UI"/>
+              </a:rPr>
+              <a:t>).</a:t>
             </a:r>
           </a:p>
         </p:txBody>
@@ -4781,9 +5259,8 @@
           <a:bodyPr wrap="square" lIns="220000" tIns="200000" rIns="220000" bIns="160000" rtlCol="0" anchor="t"/>
           <a:lstStyle/>
           <a:p>
-            <a:pPr algn="ctr"/>
-            <a:r>
-              <a:rPr sz="1700" b="1">
+            <a:r>
+              <a:rPr sz="1700" b="1" dirty="0">
                 <a:solidFill>
                   <a:srgbClr val="4F9CFF"/>
                 </a:solidFill>
@@ -4802,13 +5279,40 @@
               </a:spcBef>
             </a:pPr>
             <a:r>
-              <a:rPr sz="1250">
-                <a:solidFill>
-                  <a:srgbClr val="A8B3D1"/>
-                </a:solidFill>
-                <a:latin typeface="Segoe UI"/>
-              </a:rPr>
-              <a:t>Fluxo reprodutível de dados</a:t>
+              <a:rPr sz="1250" dirty="0" err="1">
+                <a:solidFill>
+                  <a:srgbClr val="A8B3D1"/>
+                </a:solidFill>
+                <a:latin typeface="Segoe UI"/>
+              </a:rPr>
+              <a:t>Fluxo</a:t>
+            </a:r>
+            <a:r>
+              <a:rPr sz="1250" dirty="0">
+                <a:solidFill>
+                  <a:srgbClr val="A8B3D1"/>
+                </a:solidFill>
+                <a:latin typeface="Segoe UI"/>
+              </a:rPr>
+              <a:t> </a:t>
+            </a:r>
+            <a:r>
+              <a:rPr sz="1250" dirty="0" err="1">
+                <a:solidFill>
+                  <a:srgbClr val="A8B3D1"/>
+                </a:solidFill>
+                <a:latin typeface="Segoe UI"/>
+              </a:rPr>
+              <a:t>reprodutível</a:t>
+            </a:r>
+            <a:r>
+              <a:rPr sz="1250" dirty="0">
+                <a:solidFill>
+                  <a:srgbClr val="A8B3D1"/>
+                </a:solidFill>
+                <a:latin typeface="Segoe UI"/>
+              </a:rPr>
+              <a:t> de dados</a:t>
             </a:r>
           </a:p>
           <a:p>
@@ -4821,13 +5325,49 @@
               </a:spcBef>
             </a:pPr>
             <a:r>
-              <a:rPr sz="1250">
-                <a:solidFill>
-                  <a:srgbClr val="A8B3D1"/>
-                </a:solidFill>
-                <a:latin typeface="Segoe UI"/>
-              </a:rPr>
-              <a:t>e treino, versionado e</a:t>
+              <a:rPr sz="1250" dirty="0">
+                <a:solidFill>
+                  <a:srgbClr val="A8B3D1"/>
+                </a:solidFill>
+                <a:latin typeface="Segoe UI"/>
+              </a:rPr>
+              <a:t>e </a:t>
+            </a:r>
+            <a:r>
+              <a:rPr sz="1250" dirty="0" err="1">
+                <a:solidFill>
+                  <a:srgbClr val="A8B3D1"/>
+                </a:solidFill>
+                <a:latin typeface="Segoe UI"/>
+              </a:rPr>
+              <a:t>treino</a:t>
+            </a:r>
+            <a:r>
+              <a:rPr sz="1250" dirty="0">
+                <a:solidFill>
+                  <a:srgbClr val="A8B3D1"/>
+                </a:solidFill>
+                <a:latin typeface="Segoe UI"/>
+              </a:rPr>
+              <a:t>, </a:t>
+            </a:r>
+            <a:r>
+              <a:rPr sz="1250" dirty="0" err="1">
+                <a:solidFill>
+                  <a:srgbClr val="A8B3D1"/>
+                </a:solidFill>
+                <a:latin typeface="Segoe UI"/>
+              </a:rPr>
+              <a:t>versionado</a:t>
+            </a:r>
+            <a:r>
+              <a:rPr sz="1250" dirty="0">
+                <a:solidFill>
+                  <a:srgbClr val="A8B3D1"/>
+                </a:solidFill>
+                <a:latin typeface="Segoe UI"/>
+              </a:rPr>
+              <a:t> e</a:t>
             </a:r>
           </a:p>
           <a:p>
@@ -4840,13 +5380,58 @@
               </a:spcBef>
             </a:pPr>
             <a:r>
-              <a:rPr sz="1250">
-                <a:solidFill>
-                  <a:srgbClr val="A8B3D1"/>
-                </a:solidFill>
-                <a:latin typeface="Segoe UI"/>
-              </a:rPr>
-              <a:t>rastreável de ponta a ponta.</a:t>
+              <a:rPr sz="1250" dirty="0" err="1">
+                <a:solidFill>
+                  <a:srgbClr val="A8B3D1"/>
+                </a:solidFill>
+                <a:latin typeface="Segoe UI"/>
+              </a:rPr>
+              <a:t>rastreável</a:t>
+            </a:r>
+            <a:r>
+              <a:rPr sz="1250" dirty="0">
+                <a:solidFill>
+                  <a:srgbClr val="A8B3D1"/>
+                </a:solidFill>
+                <a:latin typeface="Segoe UI"/>
+              </a:rPr>
+              <a:t> de </a:t>
+            </a:r>
+            <a:r>
+              <a:rPr sz="1250" dirty="0" err="1">
+                <a:solidFill>
+                  <a:srgbClr val="A8B3D1"/>
+                </a:solidFill>
+                <a:latin typeface="Segoe UI"/>
+              </a:rPr>
+              <a:t>ponta</a:t>
+            </a:r>
+            <a:r>
+              <a:rPr sz="1250" dirty="0">
+                <a:solidFill>
+                  <a:srgbClr val="A8B3D1"/>
+                </a:solidFill>
+                <a:latin typeface="Segoe UI"/>
+              </a:rPr>
+              <a:t> a </a:t>
+            </a:r>
+            <a:r>
+              <a:rPr sz="1250" dirty="0" err="1">
+                <a:solidFill>
+                  <a:srgbClr val="A8B3D1"/>
+                </a:solidFill>
+                <a:latin typeface="Segoe UI"/>
+              </a:rPr>
+              <a:t>ponta</a:t>
+            </a:r>
+            <a:r>
+              <a:rPr sz="1250" dirty="0">
+                <a:solidFill>
+                  <a:srgbClr val="A8B3D1"/>
+                </a:solidFill>
+                <a:latin typeface="Segoe UI"/>
+              </a:rPr>
+              <a:t>.</a:t>
             </a:r>
           </a:p>
         </p:txBody>
@@ -4891,16 +5476,30 @@
           <a:bodyPr wrap="square" lIns="220000" tIns="200000" rIns="220000" bIns="160000" rtlCol="0" anchor="t"/>
           <a:lstStyle/>
           <a:p>
-            <a:pPr algn="ctr"/>
-            <a:r>
-              <a:rPr sz="1700" b="1">
+            <a:r>
+              <a:rPr sz="1700" b="1" dirty="0">
                 <a:solidFill>
                   <a:srgbClr val="4F9CFF"/>
                 </a:solidFill>
                 <a:latin typeface="Segoe UI"/>
               </a:rPr>
-              <a:t>3 · Servir</a:t>
-            </a:r>
+              <a:t>3 · </a:t>
+            </a:r>
+            <a:r>
+              <a:rPr sz="1700" b="1" dirty="0" err="1">
+                <a:solidFill>
+                  <a:srgbClr val="4F9CFF"/>
+                </a:solidFill>
+                <a:latin typeface="Segoe UI"/>
+              </a:rPr>
+              <a:t>Servir</a:t>
+            </a:r>
+            <a:endParaRPr sz="1700" b="1" dirty="0">
+              <a:solidFill>
+                <a:srgbClr val="4F9CFF"/>
+              </a:solidFill>
+              <a:latin typeface="Segoe UI"/>
+            </a:endParaRPr>
           </a:p>
           <a:p>
             <a:pPr>
@@ -4912,13 +5511,31 @@
               </a:spcBef>
             </a:pPr>
             <a:r>
-              <a:rPr sz="1250">
-                <a:solidFill>
-                  <a:srgbClr val="A8B3D1"/>
-                </a:solidFill>
-                <a:latin typeface="Segoe UI"/>
-              </a:rPr>
-              <a:t>API REST que entrega as</a:t>
+              <a:rPr sz="1250" dirty="0">
+                <a:solidFill>
+                  <a:srgbClr val="A8B3D1"/>
+                </a:solidFill>
+                <a:latin typeface="Segoe UI"/>
+              </a:rPr>
+              <a:t>API REST que </a:t>
+            </a:r>
+            <a:r>
+              <a:rPr sz="1250" dirty="0" err="1">
+                <a:solidFill>
+                  <a:srgbClr val="A8B3D1"/>
+                </a:solidFill>
+                <a:latin typeface="Segoe UI"/>
+              </a:rPr>
+              <a:t>entrega</a:t>
+            </a:r>
+            <a:r>
+              <a:rPr sz="1250" dirty="0">
+                <a:solidFill>
+                  <a:srgbClr val="A8B3D1"/>
+                </a:solidFill>
+                <a:latin typeface="Segoe UI"/>
+              </a:rPr>
+              <a:t> as</a:t>
             </a:r>
           </a:p>
           <a:p>
@@ -4931,13 +5548,22 @@
               </a:spcBef>
             </a:pPr>
             <a:r>
-              <a:rPr sz="1250">
-                <a:solidFill>
-                  <a:srgbClr val="A8B3D1"/>
-                </a:solidFill>
-                <a:latin typeface="Segoe UI"/>
-              </a:rPr>
-              <a:t>recomendações de forma</a:t>
+              <a:rPr sz="1250" dirty="0" err="1">
+                <a:solidFill>
+                  <a:srgbClr val="A8B3D1"/>
+                </a:solidFill>
+                <a:latin typeface="Segoe UI"/>
+              </a:rPr>
+              <a:t>recomendações</a:t>
+            </a:r>
+            <a:r>
+              <a:rPr sz="1250" dirty="0">
+                <a:solidFill>
+                  <a:srgbClr val="A8B3D1"/>
+                </a:solidFill>
+                <a:latin typeface="Segoe UI"/>
+              </a:rPr>
+              <a:t> de forma</a:t>
             </a:r>
           </a:p>
           <a:p>
@@ -4950,13 +5576,40 @@
               </a:spcBef>
             </a:pPr>
             <a:r>
-              <a:rPr sz="1250">
-                <a:solidFill>
-                  <a:srgbClr val="A8B3D1"/>
-                </a:solidFill>
-                <a:latin typeface="Segoe UI"/>
-              </a:rPr>
-              <a:t>rápida e resiliente.</a:t>
+              <a:rPr sz="1250" dirty="0" err="1">
+                <a:solidFill>
+                  <a:srgbClr val="A8B3D1"/>
+                </a:solidFill>
+                <a:latin typeface="Segoe UI"/>
+              </a:rPr>
+              <a:t>rápida</a:t>
+            </a:r>
+            <a:r>
+              <a:rPr sz="1250" dirty="0">
+                <a:solidFill>
+                  <a:srgbClr val="A8B3D1"/>
+                </a:solidFill>
+                <a:latin typeface="Segoe UI"/>
+              </a:rPr>
+              <a:t> e </a:t>
+            </a:r>
+            <a:r>
+              <a:rPr sz="1250" dirty="0" err="1">
+                <a:solidFill>
+                  <a:srgbClr val="A8B3D1"/>
+                </a:solidFill>
+                <a:latin typeface="Segoe UI"/>
+              </a:rPr>
+              <a:t>resiliente</a:t>
+            </a:r>
+            <a:r>
+              <a:rPr sz="1250" dirty="0">
+                <a:solidFill>
+                  <a:srgbClr val="A8B3D1"/>
+                </a:solidFill>
+                <a:latin typeface="Segoe UI"/>
+              </a:rPr>
+              <a:t>.</a:t>
             </a:r>
           </a:p>
         </p:txBody>
@@ -5001,15 +5654,23 @@
           <a:bodyPr wrap="square" lIns="220000" tIns="200000" rIns="220000" bIns="160000" rtlCol="0" anchor="t"/>
           <a:lstStyle/>
           <a:p>
-            <a:pPr algn="ctr"/>
-            <a:r>
-              <a:rPr sz="1700" b="1">
+            <a:r>
+              <a:rPr sz="1700" b="1" dirty="0" err="1">
                 <a:solidFill>
                   <a:srgbClr val="2EE6B6"/>
                 </a:solidFill>
                 <a:latin typeface="Segoe UI"/>
               </a:rPr>
-              <a:t>Entrega principal</a:t>
+              <a:t>Entrega</a:t>
+            </a:r>
+            <a:r>
+              <a:rPr sz="1700" b="1" dirty="0">
+                <a:solidFill>
+                  <a:srgbClr val="2EE6B6"/>
+                </a:solidFill>
+                <a:latin typeface="Segoe UI"/>
+              </a:rPr>
+              <a:t> principal</a:t>
             </a:r>
           </a:p>
           <a:p>
@@ -5022,13 +5683,85 @@
               </a:spcBef>
             </a:pPr>
             <a:r>
-              <a:rPr sz="1250">
-                <a:solidFill>
-                  <a:srgbClr val="A8B3D1"/>
-                </a:solidFill>
-                <a:latin typeface="Segoe UI"/>
-              </a:rPr>
-              <a:t>Dado um user_id → retornar o TOP-K de filmes recomendados,</a:t>
+              <a:rPr sz="1250" dirty="0">
+                <a:solidFill>
+                  <a:srgbClr val="A8B3D1"/>
+                </a:solidFill>
+                <a:latin typeface="Segoe UI"/>
+              </a:rPr>
+              <a:t>Dado um </a:t>
+            </a:r>
+            <a:r>
+              <a:rPr sz="1250" dirty="0" err="1">
+                <a:solidFill>
+                  <a:srgbClr val="A8B3D1"/>
+                </a:solidFill>
+                <a:latin typeface="Segoe UI"/>
+              </a:rPr>
+              <a:t>user_id</a:t>
+            </a:r>
+            <a:r>
+              <a:rPr sz="1250" dirty="0">
+                <a:solidFill>
+                  <a:srgbClr val="A8B3D1"/>
+                </a:solidFill>
+                <a:latin typeface="Segoe UI"/>
+              </a:rPr>
+              <a:t> → </a:t>
+            </a:r>
+            <a:r>
+              <a:rPr sz="1250" dirty="0" err="1">
+                <a:solidFill>
+                  <a:srgbClr val="A8B3D1"/>
+                </a:solidFill>
+                <a:latin typeface="Segoe UI"/>
+              </a:rPr>
+              <a:t>retornar</a:t>
+            </a:r>
+            <a:r>
+              <a:rPr sz="1250" dirty="0">
+                <a:solidFill>
+                  <a:srgbClr val="A8B3D1"/>
+                </a:solidFill>
+                <a:latin typeface="Segoe UI"/>
+              </a:rPr>
+              <a:t> o TOP-K de </a:t>
+            </a:r>
+            <a:r>
+              <a:rPr sz="1250" dirty="0" err="1">
+                <a:solidFill>
+                  <a:srgbClr val="A8B3D1"/>
+                </a:solidFill>
+                <a:latin typeface="Segoe UI"/>
+              </a:rPr>
+              <a:t>filmes</a:t>
+            </a:r>
+            <a:r>
+              <a:rPr sz="1250" dirty="0">
+                <a:solidFill>
+                  <a:srgbClr val="A8B3D1"/>
+                </a:solidFill>
+                <a:latin typeface="Segoe UI"/>
+              </a:rPr>
+              <a:t> </a:t>
+            </a:r>
+            <a:r>
+              <a:rPr sz="1250" dirty="0" err="1">
+                <a:solidFill>
+                  <a:srgbClr val="A8B3D1"/>
+                </a:solidFill>
+                <a:latin typeface="Segoe UI"/>
+              </a:rPr>
+              <a:t>recomendados</a:t>
+            </a:r>
+            <a:r>
+              <a:rPr sz="1250" dirty="0">
+                <a:solidFill>
+                  <a:srgbClr val="A8B3D1"/>
+                </a:solidFill>
+                <a:latin typeface="Segoe UI"/>
+              </a:rPr>
+              <a:t>,</a:t>
             </a:r>
           </a:p>
           <a:p>
@@ -5041,13 +5774,103 @@
               </a:spcBef>
             </a:pPr>
             <a:r>
-              <a:rPr sz="1250">
-                <a:solidFill>
-                  <a:srgbClr val="A8B3D1"/>
-                </a:solidFill>
-                <a:latin typeface="Segoe UI"/>
-              </a:rPr>
-              <a:t>com título, gênero e score de probabilidade de o usuário gostar.</a:t>
+              <a:rPr sz="1250" dirty="0">
+                <a:solidFill>
+                  <a:srgbClr val="A8B3D1"/>
+                </a:solidFill>
+                <a:latin typeface="Segoe UI"/>
+              </a:rPr>
+              <a:t>com </a:t>
+            </a:r>
+            <a:r>
+              <a:rPr sz="1250" dirty="0" err="1">
+                <a:solidFill>
+                  <a:srgbClr val="A8B3D1"/>
+                </a:solidFill>
+                <a:latin typeface="Segoe UI"/>
+              </a:rPr>
+              <a:t>título</a:t>
+            </a:r>
+            <a:r>
+              <a:rPr sz="1250" dirty="0">
+                <a:solidFill>
+                  <a:srgbClr val="A8B3D1"/>
+                </a:solidFill>
+                <a:latin typeface="Segoe UI"/>
+              </a:rPr>
+              <a:t>, </a:t>
+            </a:r>
+            <a:r>
+              <a:rPr sz="1250" dirty="0" err="1">
+                <a:solidFill>
+                  <a:srgbClr val="A8B3D1"/>
+                </a:solidFill>
+                <a:latin typeface="Segoe UI"/>
+              </a:rPr>
+              <a:t>gênero</a:t>
+            </a:r>
+            <a:r>
+              <a:rPr sz="1250" dirty="0">
+                <a:solidFill>
+                  <a:srgbClr val="A8B3D1"/>
+                </a:solidFill>
+                <a:latin typeface="Segoe UI"/>
+              </a:rPr>
+              <a:t> e score de </a:t>
+            </a:r>
+            <a:r>
+              <a:rPr sz="1250" dirty="0" err="1">
+                <a:solidFill>
+                  <a:srgbClr val="A8B3D1"/>
+                </a:solidFill>
+                <a:latin typeface="Segoe UI"/>
+              </a:rPr>
+              <a:t>probabilidade</a:t>
+            </a:r>
+            <a:r>
+              <a:rPr sz="1250" dirty="0">
+                <a:solidFill>
+                  <a:srgbClr val="A8B3D1"/>
+                </a:solidFill>
+                <a:latin typeface="Segoe UI"/>
+              </a:rPr>
+              <a:t> de o </a:t>
+            </a:r>
+            <a:r>
+              <a:rPr sz="1250" dirty="0" err="1">
+                <a:solidFill>
+                  <a:srgbClr val="A8B3D1"/>
+                </a:solidFill>
+                <a:latin typeface="Segoe UI"/>
+              </a:rPr>
+              <a:t>usuário</a:t>
+            </a:r>
+            <a:r>
+              <a:rPr sz="1250" dirty="0">
+                <a:solidFill>
+                  <a:srgbClr val="A8B3D1"/>
+                </a:solidFill>
+                <a:latin typeface="Segoe UI"/>
+              </a:rPr>
+              <a:t> </a:t>
+            </a:r>
+            <a:r>
+              <a:rPr sz="1250" dirty="0" err="1">
+                <a:solidFill>
+                  <a:srgbClr val="A8B3D1"/>
+                </a:solidFill>
+                <a:latin typeface="Segoe UI"/>
+              </a:rPr>
+              <a:t>gostar</a:t>
+            </a:r>
+            <a:r>
+              <a:rPr sz="1250" dirty="0">
+                <a:solidFill>
+                  <a:srgbClr val="A8B3D1"/>
+                </a:solidFill>
+                <a:latin typeface="Segoe UI"/>
+              </a:rPr>
+              <a:t>.</a:t>
             </a:r>
           </a:p>
         </p:txBody>
@@ -5963,7 +6786,7 @@
         <p:spPr>
           <a:xfrm>
             <a:off x="680000" y="650000"/>
-            <a:ext cx="8500000" cy="900000"/>
+            <a:ext cx="8994352" cy="1198277"/>
           </a:xfrm>
           <a:prstGeom prst="rect">
             <a:avLst/>
@@ -5982,13 +6805,49 @@
               </a:lnSpc>
             </a:pPr>
             <a:r>
-              <a:rPr sz="3400" b="1">
+              <a:rPr sz="3400" b="1" dirty="0">
                 <a:solidFill>
                   <a:srgbClr val="F2F5FF"/>
                 </a:solidFill>
                 <a:latin typeface="Segoe UI"/>
               </a:rPr>
-              <a:t>O Modelo — MLP com Embeddings (PyTorch)</a:t>
+              <a:t>O </a:t>
+            </a:r>
+            <a:r>
+              <a:rPr sz="3400" b="1" dirty="0" err="1">
+                <a:solidFill>
+                  <a:srgbClr val="F2F5FF"/>
+                </a:solidFill>
+                <a:latin typeface="Segoe UI"/>
+              </a:rPr>
+              <a:t>Modelo</a:t>
+            </a:r>
+            <a:r>
+              <a:rPr sz="3400" b="1" dirty="0">
+                <a:solidFill>
+                  <a:srgbClr val="F2F5FF"/>
+                </a:solidFill>
+                <a:latin typeface="Segoe UI"/>
+              </a:rPr>
+              <a:t> — MLP com Embeddings (</a:t>
+            </a:r>
+            <a:r>
+              <a:rPr sz="3400" b="1" dirty="0" err="1">
+                <a:solidFill>
+                  <a:srgbClr val="F2F5FF"/>
+                </a:solidFill>
+                <a:latin typeface="Segoe UI"/>
+              </a:rPr>
+              <a:t>PyTorch</a:t>
+            </a:r>
+            <a:r>
+              <a:rPr sz="3400" b="1" dirty="0">
+                <a:solidFill>
+                  <a:srgbClr val="F2F5FF"/>
+                </a:solidFill>
+                <a:latin typeface="Segoe UI"/>
+              </a:rPr>
+              <a:t>)</a:t>
             </a:r>
           </a:p>
         </p:txBody>
@@ -6001,7 +6860,7 @@
         </p:nvSpPr>
         <p:spPr>
           <a:xfrm>
-            <a:off x="700000" y="1480000"/>
+            <a:off x="680000" y="1895000"/>
             <a:ext cx="900000" cy="70000"/>
           </a:xfrm>
           <a:prstGeom prst="rect">
@@ -6537,9 +7396,8 @@
           <a:bodyPr wrap="square" lIns="220000" tIns="200000" rIns="220000" bIns="160000" rtlCol="0" anchor="t"/>
           <a:lstStyle/>
           <a:p>
-            <a:pPr algn="ctr"/>
-            <a:r>
-              <a:rPr sz="1700" b="1">
+            <a:r>
+              <a:rPr sz="1700" b="1" dirty="0" err="1">
                 <a:solidFill>
                   <a:srgbClr val="4F9CFF"/>
                 </a:solidFill>
@@ -6547,6 +7405,12 @@
               </a:rPr>
               <a:t>Treinamento</a:t>
             </a:r>
+            <a:endParaRPr sz="1700" b="1" dirty="0">
+              <a:solidFill>
+                <a:srgbClr val="4F9CFF"/>
+              </a:solidFill>
+              <a:latin typeface="Segoe UI"/>
+            </a:endParaRPr>
           </a:p>
           <a:p>
             <a:pPr>
@@ -6558,14 +7422,29 @@
               </a:spcBef>
             </a:pPr>
             <a:r>
-              <a:rPr sz="1250">
-                <a:solidFill>
-                  <a:srgbClr val="A8B3D1"/>
-                </a:solidFill>
-                <a:latin typeface="Segoe UI"/>
-              </a:rPr>
-              <a:t>Loss: BCEWithLogitsLoss</a:t>
-            </a:r>
+              <a:rPr sz="1250" dirty="0">
+                <a:solidFill>
+                  <a:srgbClr val="A8B3D1"/>
+                </a:solidFill>
+                <a:latin typeface="Segoe UI"/>
+              </a:rPr>
+              <a:t>Loss: </a:t>
+            </a:r>
+            <a:r>
+              <a:rPr sz="1250" dirty="0" err="1">
+                <a:solidFill>
+                  <a:srgbClr val="A8B3D1"/>
+                </a:solidFill>
+                <a:latin typeface="Segoe UI"/>
+              </a:rPr>
+              <a:t>BCEWithLogitsLoss</a:t>
+            </a:r>
+            <a:endParaRPr sz="1250" dirty="0">
+              <a:solidFill>
+                <a:srgbClr val="A8B3D1"/>
+              </a:solidFill>
+              <a:latin typeface="Segoe UI"/>
+            </a:endParaRPr>
           </a:p>
           <a:p>
             <a:pPr>
@@ -6577,13 +7456,22 @@
               </a:spcBef>
             </a:pPr>
             <a:r>
-              <a:rPr sz="1250">
-                <a:solidFill>
-                  <a:srgbClr val="A8B3D1"/>
-                </a:solidFill>
-                <a:latin typeface="Segoe UI"/>
-              </a:rPr>
-              <a:t>Otimizador: Adam</a:t>
+              <a:rPr sz="1250" dirty="0" err="1">
+                <a:solidFill>
+                  <a:srgbClr val="A8B3D1"/>
+                </a:solidFill>
+                <a:latin typeface="Segoe UI"/>
+              </a:rPr>
+              <a:t>Otimizador</a:t>
+            </a:r>
+            <a:r>
+              <a:rPr sz="1250" dirty="0">
+                <a:solidFill>
+                  <a:srgbClr val="A8B3D1"/>
+                </a:solidFill>
+                <a:latin typeface="Segoe UI"/>
+              </a:rPr>
+              <a:t>: Adam</a:t>
             </a:r>
           </a:p>
           <a:p>
@@ -6596,14 +7484,65 @@
               </a:spcBef>
             </a:pPr>
             <a:r>
-              <a:rPr sz="1250">
-                <a:solidFill>
-                  <a:srgbClr val="A8B3D1"/>
-                </a:solidFill>
-                <a:latin typeface="Segoe UI"/>
-              </a:rPr>
-              <a:t>Early stopping na perda de validação</a:t>
-            </a:r>
+              <a:rPr sz="1250" dirty="0">
+                <a:solidFill>
+                  <a:srgbClr val="A8B3D1"/>
+                </a:solidFill>
+                <a:latin typeface="Segoe UI"/>
+              </a:rPr>
+              <a:t>Early stopping </a:t>
+            </a:r>
+            <a:r>
+              <a:rPr sz="1250" dirty="0" err="1">
+                <a:solidFill>
+                  <a:srgbClr val="A8B3D1"/>
+                </a:solidFill>
+                <a:latin typeface="Segoe UI"/>
+              </a:rPr>
+              <a:t>na</a:t>
+            </a:r>
+            <a:r>
+              <a:rPr sz="1250" dirty="0">
+                <a:solidFill>
+                  <a:srgbClr val="A8B3D1"/>
+                </a:solidFill>
+                <a:latin typeface="Segoe UI"/>
+              </a:rPr>
+              <a:t> </a:t>
+            </a:r>
+            <a:r>
+              <a:rPr sz="1250" dirty="0" err="1">
+                <a:solidFill>
+                  <a:srgbClr val="A8B3D1"/>
+                </a:solidFill>
+                <a:latin typeface="Segoe UI"/>
+              </a:rPr>
+              <a:t>perda</a:t>
+            </a:r>
+            <a:r>
+              <a:rPr sz="1250" dirty="0">
+                <a:solidFill>
+                  <a:srgbClr val="A8B3D1"/>
+                </a:solidFill>
+                <a:latin typeface="Segoe UI"/>
+              </a:rPr>
+              <a:t> de </a:t>
+            </a:r>
+            <a:r>
+              <a:rPr sz="1250" dirty="0" err="1">
+                <a:solidFill>
+                  <a:srgbClr val="A8B3D1"/>
+                </a:solidFill>
+                <a:latin typeface="Segoe UI"/>
+              </a:rPr>
+              <a:t>validação</a:t>
+            </a:r>
+            <a:endParaRPr sz="1250" dirty="0">
+              <a:solidFill>
+                <a:srgbClr val="A8B3D1"/>
+              </a:solidFill>
+              <a:latin typeface="Segoe UI"/>
+            </a:endParaRPr>
           </a:p>
           <a:p>
             <a:pPr>
@@ -6615,13 +7554,67 @@
               </a:spcBef>
             </a:pPr>
             <a:r>
-              <a:rPr sz="1250">
-                <a:solidFill>
-                  <a:srgbClr val="A8B3D1"/>
-                </a:solidFill>
-                <a:latin typeface="Segoe UI"/>
-              </a:rPr>
-              <a:t>Salva sempre o melhor modelo (.pth)</a:t>
+              <a:rPr sz="1250" dirty="0">
+                <a:solidFill>
+                  <a:srgbClr val="A8B3D1"/>
+                </a:solidFill>
+                <a:latin typeface="Segoe UI"/>
+              </a:rPr>
+              <a:t>Salva sempre o </a:t>
+            </a:r>
+            <a:r>
+              <a:rPr sz="1250" dirty="0" err="1">
+                <a:solidFill>
+                  <a:srgbClr val="A8B3D1"/>
+                </a:solidFill>
+                <a:latin typeface="Segoe UI"/>
+              </a:rPr>
+              <a:t>melhor</a:t>
+            </a:r>
+            <a:r>
+              <a:rPr sz="1250" dirty="0">
+                <a:solidFill>
+                  <a:srgbClr val="A8B3D1"/>
+                </a:solidFill>
+                <a:latin typeface="Segoe UI"/>
+              </a:rPr>
+              <a:t> </a:t>
+            </a:r>
+            <a:r>
+              <a:rPr sz="1250" dirty="0" err="1">
+                <a:solidFill>
+                  <a:srgbClr val="A8B3D1"/>
+                </a:solidFill>
+                <a:latin typeface="Segoe UI"/>
+              </a:rPr>
+              <a:t>modelo</a:t>
+            </a:r>
+            <a:r>
+              <a:rPr sz="1250" dirty="0">
+                <a:solidFill>
+                  <a:srgbClr val="A8B3D1"/>
+                </a:solidFill>
+                <a:latin typeface="Segoe UI"/>
+              </a:rPr>
+              <a:t> (.</a:t>
+            </a:r>
+            <a:r>
+              <a:rPr sz="1250" dirty="0" err="1">
+                <a:solidFill>
+                  <a:srgbClr val="A8B3D1"/>
+                </a:solidFill>
+                <a:latin typeface="Segoe UI"/>
+              </a:rPr>
+              <a:t>pth</a:t>
+            </a:r>
+            <a:r>
+              <a:rPr sz="1250" dirty="0">
+                <a:solidFill>
+                  <a:srgbClr val="A8B3D1"/>
+                </a:solidFill>
+                <a:latin typeface="Segoe UI"/>
+              </a:rPr>
+              <a:t>)</a:t>
             </a:r>
           </a:p>
         </p:txBody>
@@ -6666,16 +7659,48 @@
           <a:bodyPr wrap="square" lIns="220000" tIns="200000" rIns="220000" bIns="160000" rtlCol="0" anchor="t"/>
           <a:lstStyle/>
           <a:p>
-            <a:pPr algn="ctr"/>
-            <a:r>
-              <a:rPr sz="1700" b="1">
+            <a:r>
+              <a:rPr sz="1700" b="1" dirty="0">
                 <a:solidFill>
                   <a:srgbClr val="2EE6B6"/>
                 </a:solidFill>
                 <a:latin typeface="Segoe UI"/>
               </a:rPr>
-              <a:t>Boas práticas de projeto</a:t>
-            </a:r>
+              <a:t>Boas </a:t>
+            </a:r>
+            <a:r>
+              <a:rPr sz="1700" b="1" dirty="0" err="1">
+                <a:solidFill>
+                  <a:srgbClr val="2EE6B6"/>
+                </a:solidFill>
+                <a:latin typeface="Segoe UI"/>
+              </a:rPr>
+              <a:t>práticas</a:t>
+            </a:r>
+            <a:r>
+              <a:rPr sz="1700" b="1" dirty="0">
+                <a:solidFill>
+                  <a:srgbClr val="2EE6B6"/>
+                </a:solidFill>
+                <a:latin typeface="Segoe UI"/>
+              </a:rPr>
+              <a:t> de </a:t>
+            </a:r>
+            <a:r>
+              <a:rPr sz="1700" b="1" dirty="0" err="1">
+                <a:solidFill>
+                  <a:srgbClr val="2EE6B6"/>
+                </a:solidFill>
+                <a:latin typeface="Segoe UI"/>
+              </a:rPr>
+              <a:t>projeto</a:t>
+            </a:r>
+            <a:endParaRPr sz="1700" b="1" dirty="0">
+              <a:solidFill>
+                <a:srgbClr val="2EE6B6"/>
+              </a:solidFill>
+              <a:latin typeface="Segoe UI"/>
+            </a:endParaRPr>
           </a:p>
           <a:p>
             <a:pPr>
@@ -6687,14 +7712,47 @@
               </a:spcBef>
             </a:pPr>
             <a:r>
-              <a:rPr sz="1250">
-                <a:solidFill>
-                  <a:srgbClr val="A8B3D1"/>
-                </a:solidFill>
-                <a:latin typeface="Segoe UI"/>
-              </a:rPr>
-              <a:t>Factory Pattern para criar modelos</a:t>
-            </a:r>
+              <a:rPr sz="1250" dirty="0">
+                <a:solidFill>
+                  <a:srgbClr val="A8B3D1"/>
+                </a:solidFill>
+                <a:latin typeface="Segoe UI"/>
+              </a:rPr>
+              <a:t>Factory Pattern para </a:t>
+            </a:r>
+            <a:r>
+              <a:rPr sz="1250" dirty="0" err="1">
+                <a:solidFill>
+                  <a:srgbClr val="A8B3D1"/>
+                </a:solidFill>
+                <a:latin typeface="Segoe UI"/>
+              </a:rPr>
+              <a:t>criar</a:t>
+            </a:r>
+            <a:r>
+              <a:rPr sz="1250" dirty="0">
+                <a:solidFill>
+                  <a:srgbClr val="A8B3D1"/>
+                </a:solidFill>
+                <a:latin typeface="Segoe UI"/>
+              </a:rPr>
+              <a:t> </a:t>
+            </a:r>
+            <a:r>
+              <a:rPr sz="1250" dirty="0" err="1">
+                <a:solidFill>
+                  <a:srgbClr val="A8B3D1"/>
+                </a:solidFill>
+                <a:latin typeface="Segoe UI"/>
+              </a:rPr>
+              <a:t>modelos</a:t>
+            </a:r>
+            <a:endParaRPr sz="1250" dirty="0">
+              <a:solidFill>
+                <a:srgbClr val="A8B3D1"/>
+              </a:solidFill>
+              <a:latin typeface="Segoe UI"/>
+            </a:endParaRPr>
           </a:p>
           <a:p>
             <a:pPr>
@@ -6706,14 +7764,29 @@
               </a:spcBef>
             </a:pPr>
             <a:r>
-              <a:rPr sz="1250">
-                <a:solidFill>
-                  <a:srgbClr val="A8B3D1"/>
-                </a:solidFill>
-                <a:latin typeface="Segoe UI"/>
-              </a:rPr>
-              <a:t>Strategy Pattern no pré-processamento</a:t>
-            </a:r>
+              <a:rPr sz="1250" dirty="0">
+                <a:solidFill>
+                  <a:srgbClr val="A8B3D1"/>
+                </a:solidFill>
+                <a:latin typeface="Segoe UI"/>
+              </a:rPr>
+              <a:t>Strategy Pattern no </a:t>
+            </a:r>
+            <a:r>
+              <a:rPr sz="1250" dirty="0" err="1">
+                <a:solidFill>
+                  <a:srgbClr val="A8B3D1"/>
+                </a:solidFill>
+                <a:latin typeface="Segoe UI"/>
+              </a:rPr>
+              <a:t>pré-processamento</a:t>
+            </a:r>
+            <a:endParaRPr sz="1250" dirty="0">
+              <a:solidFill>
+                <a:srgbClr val="A8B3D1"/>
+              </a:solidFill>
+              <a:latin typeface="Segoe UI"/>
+            </a:endParaRPr>
           </a:p>
           <a:p>
             <a:pPr>
@@ -6725,14 +7798,56 @@
               </a:spcBef>
             </a:pPr>
             <a:r>
-              <a:rPr sz="1250">
-                <a:solidFill>
-                  <a:srgbClr val="A8B3D1"/>
-                </a:solidFill>
-                <a:latin typeface="Segoe UI"/>
-              </a:rPr>
-              <a:t>BaseModel abstrato → extensível</a:t>
-            </a:r>
+              <a:rPr sz="1250" dirty="0" err="1">
+                <a:solidFill>
+                  <a:srgbClr val="A8B3D1"/>
+                </a:solidFill>
+                <a:latin typeface="Segoe UI"/>
+              </a:rPr>
+              <a:t>BaseModel</a:t>
+            </a:r>
+            <a:r>
+              <a:rPr sz="1250" dirty="0">
+                <a:solidFill>
+                  <a:srgbClr val="A8B3D1"/>
+                </a:solidFill>
+                <a:latin typeface="Segoe UI"/>
+              </a:rPr>
+              <a:t> </a:t>
+            </a:r>
+            <a:r>
+              <a:rPr sz="1250" dirty="0" err="1">
+                <a:solidFill>
+                  <a:srgbClr val="A8B3D1"/>
+                </a:solidFill>
+                <a:latin typeface="Segoe UI"/>
+              </a:rPr>
+              <a:t>abstrato</a:t>
+            </a:r>
+            <a:r>
+              <a:rPr sz="1250" dirty="0">
+                <a:solidFill>
+                  <a:srgbClr val="A8B3D1"/>
+                </a:solidFill>
+                <a:latin typeface="Segoe UI"/>
+              </a:rPr>
+              <a:t> → </a:t>
+            </a:r>
+            <a:r>
+              <a:rPr sz="1250" dirty="0" err="1">
+                <a:solidFill>
+                  <a:srgbClr val="A8B3D1"/>
+                </a:solidFill>
+                <a:latin typeface="Segoe UI"/>
+              </a:rPr>
+              <a:t>extensível</a:t>
+            </a:r>
+            <a:endParaRPr sz="1250" dirty="0">
+              <a:solidFill>
+                <a:srgbClr val="A8B3D1"/>
+              </a:solidFill>
+              <a:latin typeface="Segoe UI"/>
+            </a:endParaRPr>
           </a:p>
           <a:p>
             <a:pPr>
@@ -6744,14 +7859,38 @@
               </a:spcBef>
             </a:pPr>
             <a:r>
-              <a:rPr sz="1250">
-                <a:solidFill>
-                  <a:srgbClr val="A8B3D1"/>
-                </a:solidFill>
-                <a:latin typeface="Segoe UI"/>
-              </a:rPr>
-              <a:t>set_seed() para reprodutibilidade</a:t>
-            </a:r>
+              <a:rPr sz="1250" dirty="0" err="1">
+                <a:solidFill>
+                  <a:srgbClr val="A8B3D1"/>
+                </a:solidFill>
+                <a:latin typeface="Segoe UI"/>
+              </a:rPr>
+              <a:t>set_seed</a:t>
+            </a:r>
+            <a:r>
+              <a:rPr sz="1250" dirty="0">
+                <a:solidFill>
+                  <a:srgbClr val="A8B3D1"/>
+                </a:solidFill>
+                <a:latin typeface="Segoe UI"/>
+              </a:rPr>
+              <a:t>() para </a:t>
+            </a:r>
+            <a:r>
+              <a:rPr sz="1250" dirty="0" err="1">
+                <a:solidFill>
+                  <a:srgbClr val="A8B3D1"/>
+                </a:solidFill>
+                <a:latin typeface="Segoe UI"/>
+              </a:rPr>
+              <a:t>reprodutibilidade</a:t>
+            </a:r>
+            <a:endParaRPr sz="1250" dirty="0">
+              <a:solidFill>
+                <a:srgbClr val="A8B3D1"/>
+              </a:solidFill>
+              <a:latin typeface="Segoe UI"/>
+            </a:endParaRPr>
           </a:p>
         </p:txBody>
       </p:sp>
@@ -6915,14 +8054,56 @@
               </a:lnSpc>
             </a:pPr>
             <a:r>
-              <a:rPr sz="3400" b="1">
+              <a:rPr sz="3400" b="1" dirty="0" err="1">
                 <a:solidFill>
                   <a:srgbClr val="F2F5FF"/>
                 </a:solidFill>
                 <a:latin typeface="Segoe UI"/>
               </a:rPr>
-              <a:t>MLOps — Rastreabilidade &amp; Reprodutibilidade</a:t>
-            </a:r>
+              <a:t>MLOps</a:t>
+            </a:r>
+            <a:r>
+              <a:rPr sz="3400" b="1" dirty="0">
+                <a:solidFill>
+                  <a:srgbClr val="F2F5FF"/>
+                </a:solidFill>
+                <a:latin typeface="Segoe UI"/>
+              </a:rPr>
+              <a:t> — </a:t>
+            </a:r>
+            <a:r>
+              <a:rPr sz="3400" b="1" dirty="0" err="1">
+                <a:solidFill>
+                  <a:srgbClr val="F2F5FF"/>
+                </a:solidFill>
+                <a:latin typeface="Segoe UI"/>
+              </a:rPr>
+              <a:t>Rastreabilidade</a:t>
+            </a:r>
+            <a:r>
+              <a:rPr sz="3400" b="1" dirty="0">
+                <a:solidFill>
+                  <a:srgbClr val="F2F5FF"/>
+                </a:solidFill>
+                <a:latin typeface="Segoe UI"/>
+              </a:rPr>
+              <a:t> &amp; </a:t>
+            </a:r>
+            <a:r>
+              <a:rPr sz="3400" b="1" dirty="0" err="1">
+                <a:solidFill>
+                  <a:srgbClr val="F2F5FF"/>
+                </a:solidFill>
+                <a:latin typeface="Segoe UI"/>
+              </a:rPr>
+              <a:t>Reprodutibilidade</a:t>
+            </a:r>
+            <a:endParaRPr sz="3400" b="1" dirty="0">
+              <a:solidFill>
+                <a:srgbClr val="F2F5FF"/>
+              </a:solidFill>
+              <a:latin typeface="Segoe UI"/>
+            </a:endParaRPr>
           </a:p>
         </p:txBody>
       </p:sp>
@@ -6934,7 +8115,7 @@
         </p:nvSpPr>
         <p:spPr>
           <a:xfrm>
-            <a:off x="700000" y="1480000"/>
+            <a:off x="700000" y="1822952"/>
             <a:ext cx="900000" cy="70000"/>
           </a:xfrm>
           <a:prstGeom prst="rect">
@@ -7011,9 +8192,8 @@
           <a:bodyPr wrap="square" lIns="220000" tIns="200000" rIns="220000" bIns="160000" rtlCol="0" anchor="t"/>
           <a:lstStyle/>
           <a:p>
-            <a:pPr algn="ctr"/>
-            <a:r>
-              <a:rPr sz="1700" b="1">
+            <a:r>
+              <a:rPr sz="1700" b="1" dirty="0" err="1">
                 <a:solidFill>
                   <a:srgbClr val="4F9CFF"/>
                 </a:solidFill>
@@ -7021,6 +8201,12 @@
               </a:rPr>
               <a:t>MLflow</a:t>
             </a:r>
+            <a:endParaRPr sz="1700" b="1" dirty="0">
+              <a:solidFill>
+                <a:srgbClr val="4F9CFF"/>
+              </a:solidFill>
+              <a:latin typeface="Segoe UI"/>
+            </a:endParaRPr>
           </a:p>
           <a:p>
             <a:pPr>
@@ -7032,13 +8218,58 @@
               </a:spcBef>
             </a:pPr>
             <a:r>
-              <a:rPr sz="1250">
-                <a:solidFill>
-                  <a:srgbClr val="A8B3D1"/>
-                </a:solidFill>
-                <a:latin typeface="Segoe UI"/>
-              </a:rPr>
-              <a:t>Registra cada experimento:</a:t>
+              <a:rPr sz="1250" dirty="0" err="1">
+                <a:solidFill>
+                  <a:srgbClr val="A8B3D1"/>
+                </a:solidFill>
+                <a:latin typeface="Segoe UI"/>
+              </a:rPr>
+              <a:t>Registra</a:t>
+            </a:r>
+            <a:r>
+              <a:rPr sz="1250" dirty="0">
+                <a:solidFill>
+                  <a:srgbClr val="A8B3D1"/>
+                </a:solidFill>
+                <a:latin typeface="Segoe UI"/>
+              </a:rPr>
+              <a:t> </a:t>
+            </a:r>
+            <a:r>
+              <a:rPr sz="1250" dirty="0" err="1">
+                <a:solidFill>
+                  <a:srgbClr val="A8B3D1"/>
+                </a:solidFill>
+                <a:latin typeface="Segoe UI"/>
+              </a:rPr>
+              <a:t>cada</a:t>
+            </a:r>
+            <a:r>
+              <a:rPr sz="1250" dirty="0">
+                <a:solidFill>
+                  <a:srgbClr val="A8B3D1"/>
+                </a:solidFill>
+                <a:latin typeface="Segoe UI"/>
+              </a:rPr>
+              <a:t> </a:t>
+            </a:r>
+            <a:r>
+              <a:rPr sz="1250" dirty="0" err="1">
+                <a:solidFill>
+                  <a:srgbClr val="A8B3D1"/>
+                </a:solidFill>
+                <a:latin typeface="Segoe UI"/>
+              </a:rPr>
+              <a:t>experimento</a:t>
+            </a:r>
+            <a:r>
+              <a:rPr sz="1250" dirty="0">
+                <a:solidFill>
+                  <a:srgbClr val="A8B3D1"/>
+                </a:solidFill>
+                <a:latin typeface="Segoe UI"/>
+              </a:rPr>
+              <a:t>:</a:t>
             </a:r>
           </a:p>
           <a:p>
@@ -7051,14 +8282,47 @@
               </a:spcBef>
             </a:pPr>
             <a:r>
-              <a:rPr sz="1250">
-                <a:solidFill>
-                  <a:srgbClr val="A8B3D1"/>
-                </a:solidFill>
-                <a:latin typeface="Segoe UI"/>
-              </a:rPr>
-              <a:t>• parâmetros e hiperparâmetros</a:t>
-            </a:r>
+              <a:rPr sz="1250" dirty="0">
+                <a:solidFill>
+                  <a:srgbClr val="A8B3D1"/>
+                </a:solidFill>
+                <a:latin typeface="Segoe UI"/>
+              </a:rPr>
+              <a:t>• </a:t>
+            </a:r>
+            <a:r>
+              <a:rPr sz="1250" dirty="0" err="1">
+                <a:solidFill>
+                  <a:srgbClr val="A8B3D1"/>
+                </a:solidFill>
+                <a:latin typeface="Segoe UI"/>
+              </a:rPr>
+              <a:t>parâmetros</a:t>
+            </a:r>
+            <a:r>
+              <a:rPr sz="1250" dirty="0">
+                <a:solidFill>
+                  <a:srgbClr val="A8B3D1"/>
+                </a:solidFill>
+                <a:latin typeface="Segoe UI"/>
+              </a:rPr>
+              <a:t> e </a:t>
+            </a:r>
+            <a:r>
+              <a:rPr sz="1250" dirty="0" err="1">
+                <a:solidFill>
+                  <a:srgbClr val="A8B3D1"/>
+                </a:solidFill>
+                <a:latin typeface="Segoe UI"/>
+              </a:rPr>
+              <a:t>hiperparâmetros</a:t>
+            </a:r>
+            <a:endParaRPr sz="1250" dirty="0">
+              <a:solidFill>
+                <a:srgbClr val="A8B3D1"/>
+              </a:solidFill>
+              <a:latin typeface="Segoe UI"/>
+            </a:endParaRPr>
           </a:p>
           <a:p>
             <a:pPr>
@@ -7070,14 +8334,83 @@
               </a:spcBef>
             </a:pPr>
             <a:r>
-              <a:rPr sz="1250">
-                <a:solidFill>
-                  <a:srgbClr val="A8B3D1"/>
-                </a:solidFill>
-                <a:latin typeface="Segoe UI"/>
-              </a:rPr>
-              <a:t>• train_loss e val_loss por época</a:t>
-            </a:r>
+              <a:rPr sz="1250" dirty="0">
+                <a:solidFill>
+                  <a:srgbClr val="A8B3D1"/>
+                </a:solidFill>
+                <a:latin typeface="Segoe UI"/>
+              </a:rPr>
+              <a:t>• </a:t>
+            </a:r>
+            <a:r>
+              <a:rPr sz="1250" dirty="0" err="1">
+                <a:solidFill>
+                  <a:srgbClr val="A8B3D1"/>
+                </a:solidFill>
+                <a:latin typeface="Segoe UI"/>
+              </a:rPr>
+              <a:t>train_loss</a:t>
+            </a:r>
+            <a:r>
+              <a:rPr sz="1250" dirty="0">
+                <a:solidFill>
+                  <a:srgbClr val="A8B3D1"/>
+                </a:solidFill>
+                <a:latin typeface="Segoe UI"/>
+              </a:rPr>
+              <a:t> e </a:t>
+            </a:r>
+            <a:r>
+              <a:rPr sz="1250" dirty="0" err="1">
+                <a:solidFill>
+                  <a:srgbClr val="A8B3D1"/>
+                </a:solidFill>
+                <a:latin typeface="Segoe UI"/>
+              </a:rPr>
+              <a:t>val_loss</a:t>
+            </a:r>
+            <a:r>
+              <a:rPr sz="1250" dirty="0">
+                <a:solidFill>
+                  <a:srgbClr val="A8B3D1"/>
+                </a:solidFill>
+                <a:latin typeface="Segoe UI"/>
+              </a:rPr>
+              <a:t> </a:t>
+            </a:r>
+            <a:r>
+              <a:rPr sz="1250" dirty="0" err="1">
+                <a:solidFill>
+                  <a:srgbClr val="A8B3D1"/>
+                </a:solidFill>
+                <a:latin typeface="Segoe UI"/>
+              </a:rPr>
+              <a:t>por</a:t>
+            </a:r>
+            <a:r>
+              <a:rPr sz="1250" dirty="0">
+                <a:solidFill>
+                  <a:srgbClr val="A8B3D1"/>
+                </a:solidFill>
+                <a:latin typeface="Segoe UI"/>
+              </a:rPr>
+              <a:t> </a:t>
+            </a:r>
+            <a:r>
+              <a:rPr sz="1250" dirty="0" err="1">
+                <a:solidFill>
+                  <a:srgbClr val="A8B3D1"/>
+                </a:solidFill>
+                <a:latin typeface="Segoe UI"/>
+              </a:rPr>
+              <a:t>época</a:t>
+            </a:r>
+            <a:endParaRPr lang="pt-BR" sz="1250" dirty="0">
+              <a:solidFill>
+                <a:srgbClr val="A8B3D1"/>
+              </a:solidFill>
+              <a:latin typeface="Segoe UI"/>
+            </a:endParaRPr>
           </a:p>
           <a:p>
             <a:pPr>
@@ -7089,7 +8422,7 @@
               </a:spcBef>
             </a:pPr>
             <a:r>
-              <a:rPr sz="1250">
+              <a:rPr lang="pt-BR" sz="1250" dirty="0">
                 <a:solidFill>
                   <a:srgbClr val="A8B3D1"/>
                 </a:solidFill>
@@ -7108,13 +8441,58 @@
               </a:spcBef>
             </a:pPr>
             <a:r>
-              <a:rPr sz="1250">
-                <a:solidFill>
-                  <a:srgbClr val="A8B3D1"/>
-                </a:solidFill>
-                <a:latin typeface="Segoe UI"/>
-              </a:rPr>
-              <a:t>servidor estiver indisponível.</a:t>
+              <a:rPr sz="1250" dirty="0" err="1">
+                <a:solidFill>
+                  <a:srgbClr val="A8B3D1"/>
+                </a:solidFill>
+                <a:latin typeface="Segoe UI"/>
+              </a:rPr>
+              <a:t>servidor</a:t>
+            </a:r>
+            <a:r>
+              <a:rPr sz="1250" dirty="0">
+                <a:solidFill>
+                  <a:srgbClr val="A8B3D1"/>
+                </a:solidFill>
+                <a:latin typeface="Segoe UI"/>
+              </a:rPr>
+              <a:t> </a:t>
+            </a:r>
+            <a:r>
+              <a:rPr sz="1250" dirty="0" err="1">
+                <a:solidFill>
+                  <a:srgbClr val="A8B3D1"/>
+                </a:solidFill>
+                <a:latin typeface="Segoe UI"/>
+              </a:rPr>
+              <a:t>estiver</a:t>
+            </a:r>
+            <a:r>
+              <a:rPr sz="1250" dirty="0">
+                <a:solidFill>
+                  <a:srgbClr val="A8B3D1"/>
+                </a:solidFill>
+                <a:latin typeface="Segoe UI"/>
+              </a:rPr>
+              <a:t> </a:t>
+            </a:r>
+            <a:r>
+              <a:rPr sz="1250" dirty="0" err="1">
+                <a:solidFill>
+                  <a:srgbClr val="A8B3D1"/>
+                </a:solidFill>
+                <a:latin typeface="Segoe UI"/>
+              </a:rPr>
+              <a:t>indisponível</a:t>
+            </a:r>
+            <a:r>
+              <a:rPr sz="1250" dirty="0">
+                <a:solidFill>
+                  <a:srgbClr val="A8B3D1"/>
+                </a:solidFill>
+                <a:latin typeface="Segoe UI"/>
+              </a:rPr>
+              <a:t>.</a:t>
             </a:r>
           </a:p>
         </p:txBody>
@@ -7159,9 +8537,8 @@
           <a:bodyPr wrap="square" lIns="220000" tIns="200000" rIns="220000" bIns="160000" rtlCol="0" anchor="t"/>
           <a:lstStyle/>
           <a:p>
-            <a:pPr algn="ctr"/>
-            <a:r>
-              <a:rPr sz="1700" b="1">
+            <a:r>
+              <a:rPr sz="1700" b="1" dirty="0">
                 <a:solidFill>
                   <a:srgbClr val="2EE6B6"/>
                 </a:solidFill>
@@ -7180,13 +8557,22 @@
               </a:spcBef>
             </a:pPr>
             <a:r>
-              <a:rPr sz="1250">
-                <a:solidFill>
-                  <a:srgbClr val="A8B3D1"/>
-                </a:solidFill>
-                <a:latin typeface="Segoe UI"/>
-              </a:rPr>
-              <a:t>Versionamento de dados e pipeline</a:t>
+              <a:rPr sz="1250" dirty="0" err="1">
+                <a:solidFill>
+                  <a:srgbClr val="A8B3D1"/>
+                </a:solidFill>
+                <a:latin typeface="Segoe UI"/>
+              </a:rPr>
+              <a:t>Versionamento</a:t>
+            </a:r>
+            <a:r>
+              <a:rPr sz="1250" dirty="0">
+                <a:solidFill>
+                  <a:srgbClr val="A8B3D1"/>
+                </a:solidFill>
+                <a:latin typeface="Segoe UI"/>
+              </a:rPr>
+              <a:t> de dados e pipeline</a:t>
             </a:r>
           </a:p>
           <a:p>
@@ -7199,14 +8585,74 @@
               </a:spcBef>
             </a:pPr>
             <a:r>
-              <a:rPr sz="1250">
-                <a:solidFill>
-                  <a:srgbClr val="A8B3D1"/>
-                </a:solidFill>
-                <a:latin typeface="Segoe UI"/>
-              </a:rPr>
-              <a:t>Execução automática por estágio</a:t>
-            </a:r>
+              <a:rPr sz="1250" dirty="0" err="1">
+                <a:solidFill>
+                  <a:srgbClr val="A8B3D1"/>
+                </a:solidFill>
+                <a:latin typeface="Segoe UI"/>
+              </a:rPr>
+              <a:t>Execução</a:t>
+            </a:r>
+            <a:r>
+              <a:rPr sz="1250" dirty="0">
+                <a:solidFill>
+                  <a:srgbClr val="A8B3D1"/>
+                </a:solidFill>
+                <a:latin typeface="Segoe UI"/>
+              </a:rPr>
+              <a:t> </a:t>
+            </a:r>
+            <a:r>
+              <a:rPr sz="1250" dirty="0" err="1">
+                <a:solidFill>
+                  <a:srgbClr val="A8B3D1"/>
+                </a:solidFill>
+                <a:latin typeface="Segoe UI"/>
+              </a:rPr>
+              <a:t>automática</a:t>
+            </a:r>
+            <a:r>
+              <a:rPr sz="1250" dirty="0">
+                <a:solidFill>
+                  <a:srgbClr val="A8B3D1"/>
+                </a:solidFill>
+                <a:latin typeface="Segoe UI"/>
+              </a:rPr>
+              <a:t> </a:t>
+            </a:r>
+            <a:r>
+              <a:rPr sz="1250" dirty="0" err="1">
+                <a:solidFill>
+                  <a:srgbClr val="A8B3D1"/>
+                </a:solidFill>
+                <a:latin typeface="Segoe UI"/>
+              </a:rPr>
+              <a:t>por</a:t>
+            </a:r>
+            <a:r>
+              <a:rPr sz="1250" dirty="0">
+                <a:solidFill>
+                  <a:srgbClr val="A8B3D1"/>
+                </a:solidFill>
+                <a:latin typeface="Segoe UI"/>
+              </a:rPr>
+              <a:t> </a:t>
+            </a:r>
+            <a:r>
+              <a:rPr sz="1250" dirty="0" err="1">
+                <a:solidFill>
+                  <a:srgbClr val="A8B3D1"/>
+                </a:solidFill>
+                <a:latin typeface="Segoe UI"/>
+              </a:rPr>
+              <a:t>estágio</a:t>
+            </a:r>
+            <a:endParaRPr sz="1250" dirty="0">
+              <a:solidFill>
+                <a:srgbClr val="A8B3D1"/>
+              </a:solidFill>
+              <a:latin typeface="Segoe UI"/>
+            </a:endParaRPr>
           </a:p>
           <a:p>
             <a:pPr>
@@ -7218,13 +8664,49 @@
               </a:spcBef>
             </a:pPr>
             <a:r>
-              <a:rPr sz="1250">
-                <a:solidFill>
-                  <a:srgbClr val="A8B3D1"/>
-                </a:solidFill>
-                <a:latin typeface="Segoe UI"/>
-              </a:rPr>
-              <a:t>Seeds fixas (Python/NumPy/PyTorch)</a:t>
+              <a:rPr sz="1250" dirty="0">
+                <a:solidFill>
+                  <a:srgbClr val="A8B3D1"/>
+                </a:solidFill>
+                <a:latin typeface="Segoe UI"/>
+              </a:rPr>
+              <a:t>Seeds </a:t>
+            </a:r>
+            <a:r>
+              <a:rPr sz="1250" dirty="0" err="1">
+                <a:solidFill>
+                  <a:srgbClr val="A8B3D1"/>
+                </a:solidFill>
+                <a:latin typeface="Segoe UI"/>
+              </a:rPr>
+              <a:t>fixas</a:t>
+            </a:r>
+            <a:r>
+              <a:rPr sz="1250" dirty="0">
+                <a:solidFill>
+                  <a:srgbClr val="A8B3D1"/>
+                </a:solidFill>
+                <a:latin typeface="Segoe UI"/>
+              </a:rPr>
+              <a:t> (Python/NumPy/</a:t>
+            </a:r>
+            <a:r>
+              <a:rPr sz="1250" dirty="0" err="1">
+                <a:solidFill>
+                  <a:srgbClr val="A8B3D1"/>
+                </a:solidFill>
+                <a:latin typeface="Segoe UI"/>
+              </a:rPr>
+              <a:t>PyTorch</a:t>
+            </a:r>
+            <a:r>
+              <a:rPr sz="1250" dirty="0">
+                <a:solidFill>
+                  <a:srgbClr val="A8B3D1"/>
+                </a:solidFill>
+                <a:latin typeface="Segoe UI"/>
+              </a:rPr>
+              <a:t>)</a:t>
             </a:r>
           </a:p>
           <a:p>
@@ -7237,13 +8719,67 @@
               </a:spcBef>
             </a:pPr>
             <a:r>
-              <a:rPr sz="1250">
-                <a:solidFill>
-                  <a:srgbClr val="A8B3D1"/>
-                </a:solidFill>
-                <a:latin typeface="Segoe UI"/>
-              </a:rPr>
-              <a:t>→ qualquer resultado é reproduzível.</a:t>
+              <a:rPr sz="1250" dirty="0">
+                <a:solidFill>
+                  <a:srgbClr val="A8B3D1"/>
+                </a:solidFill>
+                <a:latin typeface="Segoe UI"/>
+              </a:rPr>
+              <a:t>→ </a:t>
+            </a:r>
+            <a:r>
+              <a:rPr sz="1250" dirty="0" err="1">
+                <a:solidFill>
+                  <a:srgbClr val="A8B3D1"/>
+                </a:solidFill>
+                <a:latin typeface="Segoe UI"/>
+              </a:rPr>
+              <a:t>qualquer</a:t>
+            </a:r>
+            <a:r>
+              <a:rPr sz="1250" dirty="0">
+                <a:solidFill>
+                  <a:srgbClr val="A8B3D1"/>
+                </a:solidFill>
+                <a:latin typeface="Segoe UI"/>
+              </a:rPr>
+              <a:t> </a:t>
+            </a:r>
+            <a:r>
+              <a:rPr sz="1250" dirty="0" err="1">
+                <a:solidFill>
+                  <a:srgbClr val="A8B3D1"/>
+                </a:solidFill>
+                <a:latin typeface="Segoe UI"/>
+              </a:rPr>
+              <a:t>resultado</a:t>
+            </a:r>
+            <a:r>
+              <a:rPr sz="1250" dirty="0">
+                <a:solidFill>
+                  <a:srgbClr val="A8B3D1"/>
+                </a:solidFill>
+                <a:latin typeface="Segoe UI"/>
+              </a:rPr>
+              <a:t> é </a:t>
+            </a:r>
+            <a:r>
+              <a:rPr sz="1250" dirty="0" err="1">
+                <a:solidFill>
+                  <a:srgbClr val="A8B3D1"/>
+                </a:solidFill>
+                <a:latin typeface="Segoe UI"/>
+              </a:rPr>
+              <a:t>reproduzível</a:t>
+            </a:r>
+            <a:r>
+              <a:rPr sz="1250" dirty="0">
+                <a:solidFill>
+                  <a:srgbClr val="A8B3D1"/>
+                </a:solidFill>
+                <a:latin typeface="Segoe UI"/>
+              </a:rPr>
+              <a:t>.</a:t>
             </a:r>
           </a:p>
         </p:txBody>
@@ -7288,16 +8824,30 @@
           <a:bodyPr wrap="square" lIns="220000" tIns="200000" rIns="220000" bIns="160000" rtlCol="0" anchor="t"/>
           <a:lstStyle/>
           <a:p>
-            <a:pPr algn="ctr"/>
-            <a:r>
-              <a:rPr sz="1700" b="1">
+            <a:r>
+              <a:rPr sz="1700" b="1" dirty="0">
                 <a:solidFill>
                   <a:srgbClr val="4F9CFF"/>
                 </a:solidFill>
                 <a:latin typeface="Segoe UI"/>
               </a:rPr>
-              <a:t>Por que importa</a:t>
-            </a:r>
+              <a:t>Por que </a:t>
+            </a:r>
+            <a:r>
+              <a:rPr sz="1700" b="1" dirty="0" err="1">
+                <a:solidFill>
+                  <a:srgbClr val="4F9CFF"/>
+                </a:solidFill>
+                <a:latin typeface="Segoe UI"/>
+              </a:rPr>
+              <a:t>importa</a:t>
+            </a:r>
+            <a:endParaRPr sz="1700" b="1" dirty="0">
+              <a:solidFill>
+                <a:srgbClr val="4F9CFF"/>
+              </a:solidFill>
+              <a:latin typeface="Segoe UI"/>
+            </a:endParaRPr>
           </a:p>
           <a:p>
             <a:pPr>
@@ -7309,13 +8859,166 @@
               </a:spcBef>
             </a:pPr>
             <a:r>
-              <a:rPr sz="1250">
-                <a:solidFill>
-                  <a:srgbClr val="A8B3D1"/>
-                </a:solidFill>
-                <a:latin typeface="Segoe UI"/>
-              </a:rPr>
-              <a:t>Confiança nos resultados, comparação justa de experimentos e evolução segura do modelo.</a:t>
+              <a:rPr sz="1250" dirty="0" err="1">
+                <a:solidFill>
+                  <a:srgbClr val="A8B3D1"/>
+                </a:solidFill>
+                <a:latin typeface="Segoe UI"/>
+              </a:rPr>
+              <a:t>Confiança</a:t>
+            </a:r>
+            <a:r>
+              <a:rPr sz="1250" dirty="0">
+                <a:solidFill>
+                  <a:srgbClr val="A8B3D1"/>
+                </a:solidFill>
+                <a:latin typeface="Segoe UI"/>
+              </a:rPr>
+              <a:t> </a:t>
+            </a:r>
+            <a:r>
+              <a:rPr sz="1250" dirty="0" err="1">
+                <a:solidFill>
+                  <a:srgbClr val="A8B3D1"/>
+                </a:solidFill>
+                <a:latin typeface="Segoe UI"/>
+              </a:rPr>
+              <a:t>nos</a:t>
+            </a:r>
+            <a:r>
+              <a:rPr sz="1250" dirty="0">
+                <a:solidFill>
+                  <a:srgbClr val="A8B3D1"/>
+                </a:solidFill>
+                <a:latin typeface="Segoe UI"/>
+              </a:rPr>
+              <a:t> </a:t>
+            </a:r>
+            <a:r>
+              <a:rPr sz="1250" dirty="0" err="1">
+                <a:solidFill>
+                  <a:srgbClr val="A8B3D1"/>
+                </a:solidFill>
+                <a:latin typeface="Segoe UI"/>
+              </a:rPr>
+              <a:t>resultados</a:t>
+            </a:r>
+            <a:r>
+              <a:rPr sz="1250" dirty="0">
+                <a:solidFill>
+                  <a:srgbClr val="A8B3D1"/>
+                </a:solidFill>
+                <a:latin typeface="Segoe UI"/>
+              </a:rPr>
+              <a:t>, </a:t>
+            </a:r>
+            <a:r>
+              <a:rPr sz="1250" dirty="0" err="1">
+                <a:solidFill>
+                  <a:srgbClr val="A8B3D1"/>
+                </a:solidFill>
+                <a:latin typeface="Segoe UI"/>
+              </a:rPr>
+              <a:t>comparação</a:t>
+            </a:r>
+            <a:r>
+              <a:rPr sz="1250" dirty="0">
+                <a:solidFill>
+                  <a:srgbClr val="A8B3D1"/>
+                </a:solidFill>
+                <a:latin typeface="Segoe UI"/>
+              </a:rPr>
+              <a:t> </a:t>
+            </a:r>
+            <a:r>
+              <a:rPr sz="1250" dirty="0" err="1">
+                <a:solidFill>
+                  <a:srgbClr val="A8B3D1"/>
+                </a:solidFill>
+                <a:latin typeface="Segoe UI"/>
+              </a:rPr>
+              <a:t>justa</a:t>
+            </a:r>
+            <a:r>
+              <a:rPr sz="1250" dirty="0">
+                <a:solidFill>
+                  <a:srgbClr val="A8B3D1"/>
+                </a:solidFill>
+                <a:latin typeface="Segoe UI"/>
+              </a:rPr>
+              <a:t> de </a:t>
+            </a:r>
+            <a:r>
+              <a:rPr sz="1250" dirty="0" err="1">
+                <a:solidFill>
+                  <a:srgbClr val="A8B3D1"/>
+                </a:solidFill>
+                <a:latin typeface="Segoe UI"/>
+              </a:rPr>
+              <a:t>experimentos</a:t>
+            </a:r>
+            <a:r>
+              <a:rPr sz="1250" dirty="0">
+                <a:solidFill>
+                  <a:srgbClr val="A8B3D1"/>
+                </a:solidFill>
+                <a:latin typeface="Segoe UI"/>
+              </a:rPr>
+              <a:t> e </a:t>
+            </a:r>
+            <a:r>
+              <a:rPr sz="1250" dirty="0" err="1">
+                <a:solidFill>
+                  <a:srgbClr val="A8B3D1"/>
+                </a:solidFill>
+                <a:latin typeface="Segoe UI"/>
+              </a:rPr>
+              <a:t>evolução</a:t>
+            </a:r>
+            <a:r>
+              <a:rPr sz="1250" dirty="0">
+                <a:solidFill>
+                  <a:srgbClr val="A8B3D1"/>
+                </a:solidFill>
+                <a:latin typeface="Segoe UI"/>
+              </a:rPr>
+              <a:t> </a:t>
+            </a:r>
+            <a:r>
+              <a:rPr sz="1250" dirty="0" err="1">
+                <a:solidFill>
+                  <a:srgbClr val="A8B3D1"/>
+                </a:solidFill>
+                <a:latin typeface="Segoe UI"/>
+              </a:rPr>
+              <a:t>segura</a:t>
+            </a:r>
+            <a:r>
+              <a:rPr sz="1250" dirty="0">
+                <a:solidFill>
+                  <a:srgbClr val="A8B3D1"/>
+                </a:solidFill>
+                <a:latin typeface="Segoe UI"/>
+              </a:rPr>
+              <a:t> do </a:t>
+            </a:r>
+            <a:r>
+              <a:rPr sz="1250" dirty="0" err="1">
+                <a:solidFill>
+                  <a:srgbClr val="A8B3D1"/>
+                </a:solidFill>
+                <a:latin typeface="Segoe UI"/>
+              </a:rPr>
+              <a:t>modelo</a:t>
+            </a:r>
+            <a:r>
+              <a:rPr sz="1250" dirty="0">
+                <a:solidFill>
+                  <a:srgbClr val="A8B3D1"/>
+                </a:solidFill>
+                <a:latin typeface="Segoe UI"/>
+              </a:rPr>
+              <a:t>.</a:t>
             </a:r>
           </a:p>
         </p:txBody>
@@ -7386,7 +9089,7 @@
           <a:lstStyle/>
           <a:p>
             <a:pPr algn="ctr"/>
-            <a:endParaRPr/>
+            <a:endParaRPr dirty="0"/>
           </a:p>
         </p:txBody>
       </p:sp>
@@ -7675,15 +9378,23 @@
           <a:bodyPr wrap="square" lIns="220000" tIns="200000" rIns="220000" bIns="160000" rtlCol="0" anchor="t"/>
           <a:lstStyle/>
           <a:p>
-            <a:pPr algn="ctr"/>
-            <a:r>
-              <a:rPr sz="1700" b="1">
+            <a:r>
+              <a:rPr sz="1700" b="1" dirty="0" err="1">
                 <a:solidFill>
                   <a:srgbClr val="2EE6B6"/>
                 </a:solidFill>
                 <a:latin typeface="Segoe UI"/>
               </a:rPr>
-              <a:t>Resiliência (fallback)</a:t>
+              <a:t>Resiliência</a:t>
+            </a:r>
+            <a:r>
+              <a:rPr sz="1700" b="1" dirty="0">
+                <a:solidFill>
+                  <a:srgbClr val="2EE6B6"/>
+                </a:solidFill>
+                <a:latin typeface="Segoe UI"/>
+              </a:rPr>
+              <a:t> (fallback)</a:t>
             </a:r>
           </a:p>
           <a:p>
@@ -7696,13 +9407,67 @@
               </a:spcBef>
             </a:pPr>
             <a:r>
-              <a:rPr sz="1250">
-                <a:solidFill>
-                  <a:srgbClr val="A8B3D1"/>
-                </a:solidFill>
-                <a:latin typeface="Segoe UI"/>
-              </a:rPr>
-              <a:t>Sem modelo ou usuário novo (cold-start)?</a:t>
+              <a:rPr sz="1250" dirty="0">
+                <a:solidFill>
+                  <a:srgbClr val="A8B3D1"/>
+                </a:solidFill>
+                <a:latin typeface="Segoe UI"/>
+              </a:rPr>
+              <a:t>Sem </a:t>
+            </a:r>
+            <a:r>
+              <a:rPr sz="1250" dirty="0" err="1">
+                <a:solidFill>
+                  <a:srgbClr val="A8B3D1"/>
+                </a:solidFill>
+                <a:latin typeface="Segoe UI"/>
+              </a:rPr>
+              <a:t>modelo</a:t>
+            </a:r>
+            <a:r>
+              <a:rPr sz="1250" dirty="0">
+                <a:solidFill>
+                  <a:srgbClr val="A8B3D1"/>
+                </a:solidFill>
+                <a:latin typeface="Segoe UI"/>
+              </a:rPr>
+              <a:t> </a:t>
+            </a:r>
+            <a:r>
+              <a:rPr sz="1250" dirty="0" err="1">
+                <a:solidFill>
+                  <a:srgbClr val="A8B3D1"/>
+                </a:solidFill>
+                <a:latin typeface="Segoe UI"/>
+              </a:rPr>
+              <a:t>ou</a:t>
+            </a:r>
+            <a:r>
+              <a:rPr sz="1250" dirty="0">
+                <a:solidFill>
+                  <a:srgbClr val="A8B3D1"/>
+                </a:solidFill>
+                <a:latin typeface="Segoe UI"/>
+              </a:rPr>
+              <a:t> </a:t>
+            </a:r>
+            <a:r>
+              <a:rPr sz="1250" dirty="0" err="1">
+                <a:solidFill>
+                  <a:srgbClr val="A8B3D1"/>
+                </a:solidFill>
+                <a:latin typeface="Segoe UI"/>
+              </a:rPr>
+              <a:t>usuário</a:t>
+            </a:r>
+            <a:r>
+              <a:rPr sz="1250" dirty="0">
+                <a:solidFill>
+                  <a:srgbClr val="A8B3D1"/>
+                </a:solidFill>
+                <a:latin typeface="Segoe UI"/>
+              </a:rPr>
+              <a:t> novo (cold-start)?</a:t>
             </a:r>
           </a:p>
           <a:p>
@@ -7715,13 +9480,67 @@
               </a:spcBef>
             </a:pPr>
             <a:r>
-              <a:rPr sz="1250">
-                <a:solidFill>
-                  <a:srgbClr val="A8B3D1"/>
-                </a:solidFill>
-                <a:latin typeface="Segoe UI"/>
-              </a:rPr>
-              <a:t>→ recomenda por popularidade.</a:t>
+              <a:rPr sz="1250" dirty="0">
+                <a:solidFill>
+                  <a:srgbClr val="A8B3D1"/>
+                </a:solidFill>
+                <a:latin typeface="Segoe UI"/>
+              </a:rPr>
+              <a:t>→ </a:t>
+            </a:r>
+            <a:r>
+              <a:rPr sz="1250" dirty="0" err="1">
+                <a:solidFill>
+                  <a:srgbClr val="A8B3D1"/>
+                </a:solidFill>
+                <a:latin typeface="Segoe UI"/>
+              </a:rPr>
+              <a:t>recomenda</a:t>
+            </a:r>
+            <a:r>
+              <a:rPr sz="1250" dirty="0">
+                <a:solidFill>
+                  <a:srgbClr val="A8B3D1"/>
+                </a:solidFill>
+                <a:latin typeface="Segoe UI"/>
+              </a:rPr>
+              <a:t> </a:t>
+            </a:r>
+            <a:r>
+              <a:rPr sz="1250" dirty="0" err="1">
+                <a:solidFill>
+                  <a:srgbClr val="A8B3D1"/>
+                </a:solidFill>
+                <a:latin typeface="Segoe UI"/>
+              </a:rPr>
+              <a:t>por</a:t>
+            </a:r>
+            <a:r>
+              <a:rPr sz="1250" dirty="0">
+                <a:solidFill>
+                  <a:srgbClr val="A8B3D1"/>
+                </a:solidFill>
+                <a:latin typeface="Segoe UI"/>
+              </a:rPr>
+              <a:t> </a:t>
+            </a:r>
+            <a:r>
+              <a:rPr sz="1250" dirty="0" err="1">
+                <a:solidFill>
+                  <a:srgbClr val="A8B3D1"/>
+                </a:solidFill>
+                <a:latin typeface="Segoe UI"/>
+              </a:rPr>
+              <a:t>popularidade</a:t>
+            </a:r>
+            <a:r>
+              <a:rPr sz="1250" dirty="0">
+                <a:solidFill>
+                  <a:srgbClr val="A8B3D1"/>
+                </a:solidFill>
+                <a:latin typeface="Segoe UI"/>
+              </a:rPr>
+              <a:t>.</a:t>
             </a:r>
           </a:p>
           <a:p>
@@ -7734,13 +9553,67 @@
               </a:spcBef>
             </a:pPr>
             <a:r>
-              <a:rPr sz="1250">
-                <a:solidFill>
-                  <a:srgbClr val="A8B3D1"/>
-                </a:solidFill>
-                <a:latin typeface="Segoe UI"/>
-              </a:rPr>
-              <a:t>O sistema nunca quebra.</a:t>
+              <a:rPr sz="1250" dirty="0">
+                <a:solidFill>
+                  <a:srgbClr val="A8B3D1"/>
+                </a:solidFill>
+                <a:latin typeface="Segoe UI"/>
+              </a:rPr>
+              <a:t>O </a:t>
+            </a:r>
+            <a:r>
+              <a:rPr sz="1250" dirty="0" err="1">
+                <a:solidFill>
+                  <a:srgbClr val="A8B3D1"/>
+                </a:solidFill>
+                <a:latin typeface="Segoe UI"/>
+              </a:rPr>
+              <a:t>sistema</a:t>
+            </a:r>
+            <a:r>
+              <a:rPr sz="1250" dirty="0">
+                <a:solidFill>
+                  <a:srgbClr val="A8B3D1"/>
+                </a:solidFill>
+                <a:latin typeface="Segoe UI"/>
+              </a:rPr>
+              <a:t> </a:t>
+            </a:r>
+            <a:r>
+              <a:rPr sz="1250" dirty="0" err="1">
+                <a:solidFill>
+                  <a:srgbClr val="A8B3D1"/>
+                </a:solidFill>
+                <a:latin typeface="Segoe UI"/>
+              </a:rPr>
+              <a:t>nunca</a:t>
+            </a:r>
+            <a:r>
+              <a:rPr sz="1250" dirty="0">
+                <a:solidFill>
+                  <a:srgbClr val="A8B3D1"/>
+                </a:solidFill>
+                <a:latin typeface="Segoe UI"/>
+              </a:rPr>
+              <a:t> </a:t>
+            </a:r>
+            <a:r>
+              <a:rPr sz="1250" dirty="0" err="1">
+                <a:solidFill>
+                  <a:srgbClr val="A8B3D1"/>
+                </a:solidFill>
+                <a:latin typeface="Segoe UI"/>
+              </a:rPr>
+              <a:t>quebra</a:t>
+            </a:r>
+            <a:r>
+              <a:rPr sz="1250" dirty="0">
+                <a:solidFill>
+                  <a:srgbClr val="A8B3D1"/>
+                </a:solidFill>
+                <a:latin typeface="Segoe UI"/>
+              </a:rPr>
+              <a:t>.</a:t>
             </a:r>
           </a:p>
         </p:txBody>
@@ -7785,16 +9658,39 @@
           <a:bodyPr wrap="square" lIns="220000" tIns="200000" rIns="220000" bIns="160000" rtlCol="0" anchor="t"/>
           <a:lstStyle/>
           <a:p>
-            <a:pPr algn="ctr"/>
-            <a:r>
-              <a:rPr sz="1700" b="1">
+            <a:r>
+              <a:rPr sz="1700" b="1" dirty="0" err="1">
                 <a:solidFill>
                   <a:srgbClr val="4F9CFF"/>
                 </a:solidFill>
                 <a:latin typeface="Segoe UI"/>
               </a:rPr>
-              <a:t>Exemplo de chamada</a:t>
-            </a:r>
+              <a:t>Exemplo</a:t>
+            </a:r>
+            <a:r>
+              <a:rPr sz="1700" b="1" dirty="0">
+                <a:solidFill>
+                  <a:srgbClr val="4F9CFF"/>
+                </a:solidFill>
+                <a:latin typeface="Segoe UI"/>
+              </a:rPr>
+              <a:t> de </a:t>
+            </a:r>
+            <a:r>
+              <a:rPr sz="1700" b="1" dirty="0" err="1">
+                <a:solidFill>
+                  <a:srgbClr val="4F9CFF"/>
+                </a:solidFill>
+                <a:latin typeface="Segoe UI"/>
+              </a:rPr>
+              <a:t>chamada</a:t>
+            </a:r>
+            <a:endParaRPr sz="1700" b="1" dirty="0">
+              <a:solidFill>
+                <a:srgbClr val="4F9CFF"/>
+              </a:solidFill>
+              <a:latin typeface="Segoe UI"/>
+            </a:endParaRPr>
           </a:p>
           <a:p>
             <a:pPr>
@@ -7806,13 +9702,31 @@
               </a:spcBef>
             </a:pPr>
             <a:r>
-              <a:rPr sz="1250">
-                <a:solidFill>
-                  <a:srgbClr val="A8B3D1"/>
-                </a:solidFill>
-                <a:latin typeface="Segoe UI"/>
-              </a:rPr>
-              <a:t>POST /api/v1/recommend</a:t>
+              <a:rPr sz="1250" dirty="0">
+                <a:solidFill>
+                  <a:srgbClr val="A8B3D1"/>
+                </a:solidFill>
+                <a:latin typeface="Segoe UI"/>
+              </a:rPr>
+              <a:t>POST /</a:t>
+            </a:r>
+            <a:r>
+              <a:rPr sz="1250" dirty="0" err="1">
+                <a:solidFill>
+                  <a:srgbClr val="A8B3D1"/>
+                </a:solidFill>
+                <a:latin typeface="Segoe UI"/>
+              </a:rPr>
+              <a:t>api</a:t>
+            </a:r>
+            <a:r>
+              <a:rPr sz="1250" dirty="0">
+                <a:solidFill>
+                  <a:srgbClr val="A8B3D1"/>
+                </a:solidFill>
+                <a:latin typeface="Segoe UI"/>
+              </a:rPr>
+              <a:t>/v1/recommend</a:t>
             </a:r>
           </a:p>
           <a:p>
@@ -7825,13 +9739,49 @@
               </a:spcBef>
             </a:pPr>
             <a:r>
-              <a:rPr sz="1250">
-                <a:solidFill>
-                  <a:srgbClr val="A8B3D1"/>
-                </a:solidFill>
-                <a:latin typeface="Segoe UI"/>
-              </a:rPr>
-              <a:t>{ "user_id": 1, "top_k": 10 }</a:t>
+              <a:rPr sz="1250" dirty="0">
+                <a:solidFill>
+                  <a:srgbClr val="A8B3D1"/>
+                </a:solidFill>
+                <a:latin typeface="Segoe UI"/>
+              </a:rPr>
+              <a:t>{ "</a:t>
+            </a:r>
+            <a:r>
+              <a:rPr sz="1250" dirty="0" err="1">
+                <a:solidFill>
+                  <a:srgbClr val="A8B3D1"/>
+                </a:solidFill>
+                <a:latin typeface="Segoe UI"/>
+              </a:rPr>
+              <a:t>user_id</a:t>
+            </a:r>
+            <a:r>
+              <a:rPr sz="1250" dirty="0">
+                <a:solidFill>
+                  <a:srgbClr val="A8B3D1"/>
+                </a:solidFill>
+                <a:latin typeface="Segoe UI"/>
+              </a:rPr>
+              <a:t>": 1, "</a:t>
+            </a:r>
+            <a:r>
+              <a:rPr sz="1250" dirty="0" err="1">
+                <a:solidFill>
+                  <a:srgbClr val="A8B3D1"/>
+                </a:solidFill>
+                <a:latin typeface="Segoe UI"/>
+              </a:rPr>
+              <a:t>top_k</a:t>
+            </a:r>
+            <a:r>
+              <a:rPr sz="1250" dirty="0">
+                <a:solidFill>
+                  <a:srgbClr val="A8B3D1"/>
+                </a:solidFill>
+                <a:latin typeface="Segoe UI"/>
+              </a:rPr>
+              <a:t>": 10 }</a:t>
             </a:r>
           </a:p>
           <a:p>
@@ -7844,13 +9794,31 @@
               </a:spcBef>
             </a:pPr>
             <a:r>
-              <a:rPr sz="1250">
-                <a:solidFill>
-                  <a:srgbClr val="A8B3D1"/>
-                </a:solidFill>
-                <a:latin typeface="Segoe UI"/>
-              </a:rPr>
-              <a:t>→ top-K filmes com score</a:t>
+              <a:rPr sz="1250" dirty="0">
+                <a:solidFill>
+                  <a:srgbClr val="A8B3D1"/>
+                </a:solidFill>
+                <a:latin typeface="Segoe UI"/>
+              </a:rPr>
+              <a:t>→ top-K </a:t>
+            </a:r>
+            <a:r>
+              <a:rPr sz="1250" dirty="0" err="1">
+                <a:solidFill>
+                  <a:srgbClr val="A8B3D1"/>
+                </a:solidFill>
+                <a:latin typeface="Segoe UI"/>
+              </a:rPr>
+              <a:t>filmes</a:t>
+            </a:r>
+            <a:r>
+              <a:rPr sz="1250" dirty="0">
+                <a:solidFill>
+                  <a:srgbClr val="A8B3D1"/>
+                </a:solidFill>
+                <a:latin typeface="Segoe UI"/>
+              </a:rPr>
+              <a:t> com score</a:t>
             </a:r>
           </a:p>
         </p:txBody>
@@ -8553,7 +10521,7 @@
           <a:p>
             <a:pPr algn="ctr"/>
             <a:r>
-              <a:rPr sz="1700" b="1">
+              <a:rPr sz="1700" b="1" dirty="0" err="1">
                 <a:solidFill>
                   <a:srgbClr val="2EE6B6"/>
                 </a:solidFill>
@@ -8561,9 +10529,15 @@
               </a:rPr>
               <a:t>Destaque</a:t>
             </a:r>
-          </a:p>
-          <a:p>
-            <a:pPr>
+            <a:endParaRPr sz="1700" b="1" dirty="0">
+              <a:solidFill>
+                <a:srgbClr val="2EE6B6"/>
+              </a:solidFill>
+              <a:latin typeface="Segoe UI"/>
+            </a:endParaRPr>
+          </a:p>
+          <a:p>
+            <a:pPr algn="ctr">
               <a:lnSpc>
                 <a:spcPct val="108000"/>
               </a:lnSpc>
@@ -8572,13 +10546,229 @@
               </a:spcBef>
             </a:pPr>
             <a:r>
-              <a:rPr sz="1250">
-                <a:solidFill>
-                  <a:srgbClr val="A8B3D1"/>
-                </a:solidFill>
-                <a:latin typeface="Segoe UI"/>
-              </a:rPr>
-              <a:t>A suíte roda em ~6 segundos numa máquina limpa, sem exigir um modelo treinado (artefatos fake em fixtures).</a:t>
+              <a:rPr sz="1250" dirty="0">
+                <a:solidFill>
+                  <a:srgbClr val="A8B3D1"/>
+                </a:solidFill>
+                <a:latin typeface="Segoe UI"/>
+              </a:rPr>
+              <a:t>A </a:t>
+            </a:r>
+            <a:r>
+              <a:rPr sz="1250" dirty="0" err="1">
+                <a:solidFill>
+                  <a:srgbClr val="A8B3D1"/>
+                </a:solidFill>
+                <a:latin typeface="Segoe UI"/>
+              </a:rPr>
+              <a:t>suíte</a:t>
+            </a:r>
+            <a:r>
+              <a:rPr sz="1250" dirty="0">
+                <a:solidFill>
+                  <a:srgbClr val="A8B3D1"/>
+                </a:solidFill>
+                <a:latin typeface="Segoe UI"/>
+              </a:rPr>
+              <a:t> </a:t>
+            </a:r>
+            <a:r>
+              <a:rPr sz="1250" dirty="0" err="1">
+                <a:solidFill>
+                  <a:srgbClr val="A8B3D1"/>
+                </a:solidFill>
+                <a:latin typeface="Segoe UI"/>
+              </a:rPr>
+              <a:t>roda</a:t>
+            </a:r>
+            <a:r>
+              <a:rPr sz="1250" dirty="0">
+                <a:solidFill>
+                  <a:srgbClr val="A8B3D1"/>
+                </a:solidFill>
+                <a:latin typeface="Segoe UI"/>
+              </a:rPr>
+              <a:t> </a:t>
+            </a:r>
+            <a:r>
+              <a:rPr sz="1250" dirty="0" err="1">
+                <a:solidFill>
+                  <a:srgbClr val="A8B3D1"/>
+                </a:solidFill>
+                <a:latin typeface="Segoe UI"/>
+              </a:rPr>
+              <a:t>em</a:t>
+            </a:r>
+            <a:r>
+              <a:rPr sz="1250" dirty="0">
+                <a:solidFill>
+                  <a:srgbClr val="A8B3D1"/>
+                </a:solidFill>
+                <a:latin typeface="Segoe UI"/>
+              </a:rPr>
+              <a:t> ~6 </a:t>
+            </a:r>
+            <a:r>
+              <a:rPr sz="1250" dirty="0" err="1">
+                <a:solidFill>
+                  <a:srgbClr val="A8B3D1"/>
+                </a:solidFill>
+                <a:latin typeface="Segoe UI"/>
+              </a:rPr>
+              <a:t>segundos</a:t>
+            </a:r>
+            <a:r>
+              <a:rPr sz="1250" dirty="0">
+                <a:solidFill>
+                  <a:srgbClr val="A8B3D1"/>
+                </a:solidFill>
+                <a:latin typeface="Segoe UI"/>
+              </a:rPr>
+              <a:t> </a:t>
+            </a:r>
+            <a:r>
+              <a:rPr sz="1250" dirty="0" err="1">
+                <a:solidFill>
+                  <a:srgbClr val="A8B3D1"/>
+                </a:solidFill>
+                <a:latin typeface="Segoe UI"/>
+              </a:rPr>
+              <a:t>numa</a:t>
+            </a:r>
+            <a:r>
+              <a:rPr sz="1250" dirty="0">
+                <a:solidFill>
+                  <a:srgbClr val="A8B3D1"/>
+                </a:solidFill>
+                <a:latin typeface="Segoe UI"/>
+              </a:rPr>
+              <a:t> </a:t>
+            </a:r>
+            <a:r>
+              <a:rPr sz="1250" dirty="0" err="1">
+                <a:solidFill>
+                  <a:srgbClr val="A8B3D1"/>
+                </a:solidFill>
+                <a:latin typeface="Segoe UI"/>
+              </a:rPr>
+              <a:t>máquina</a:t>
+            </a:r>
+            <a:r>
+              <a:rPr sz="1250" dirty="0">
+                <a:solidFill>
+                  <a:srgbClr val="A8B3D1"/>
+                </a:solidFill>
+                <a:latin typeface="Segoe UI"/>
+              </a:rPr>
+              <a:t> limpa, </a:t>
+            </a:r>
+            <a:r>
+              <a:rPr sz="1250" dirty="0" err="1">
+                <a:solidFill>
+                  <a:srgbClr val="A8B3D1"/>
+                </a:solidFill>
+                <a:latin typeface="Segoe UI"/>
+              </a:rPr>
+              <a:t>sem</a:t>
+            </a:r>
+            <a:r>
+              <a:rPr sz="1250" dirty="0">
+                <a:solidFill>
+                  <a:srgbClr val="A8B3D1"/>
+                </a:solidFill>
+                <a:latin typeface="Segoe UI"/>
+              </a:rPr>
+              <a:t> </a:t>
+            </a:r>
+            <a:r>
+              <a:rPr sz="1250" dirty="0" err="1">
+                <a:solidFill>
+                  <a:srgbClr val="A8B3D1"/>
+                </a:solidFill>
+                <a:latin typeface="Segoe UI"/>
+              </a:rPr>
+              <a:t>exigir</a:t>
+            </a:r>
+            <a:r>
+              <a:rPr sz="1250" dirty="0">
+                <a:solidFill>
+                  <a:srgbClr val="A8B3D1"/>
+                </a:solidFill>
+                <a:latin typeface="Segoe UI"/>
+              </a:rPr>
+              <a:t> um </a:t>
+            </a:r>
+            <a:r>
+              <a:rPr sz="1250" dirty="0" err="1">
+                <a:solidFill>
+                  <a:srgbClr val="A8B3D1"/>
+                </a:solidFill>
+                <a:latin typeface="Segoe UI"/>
+              </a:rPr>
+              <a:t>modelo</a:t>
+            </a:r>
+            <a:r>
+              <a:rPr sz="1250" dirty="0">
+                <a:solidFill>
+                  <a:srgbClr val="A8B3D1"/>
+                </a:solidFill>
+                <a:latin typeface="Segoe UI"/>
+              </a:rPr>
+              <a:t> </a:t>
+            </a:r>
+            <a:r>
+              <a:rPr sz="1250" dirty="0" err="1">
+                <a:solidFill>
+                  <a:srgbClr val="A8B3D1"/>
+                </a:solidFill>
+                <a:latin typeface="Segoe UI"/>
+              </a:rPr>
+              <a:t>treinado</a:t>
+            </a:r>
+            <a:r>
+              <a:rPr sz="1250" dirty="0">
+                <a:solidFill>
+                  <a:srgbClr val="A8B3D1"/>
+                </a:solidFill>
+                <a:latin typeface="Segoe UI"/>
+              </a:rPr>
+              <a:t> (</a:t>
+            </a:r>
+            <a:r>
+              <a:rPr sz="1250" dirty="0" err="1">
+                <a:solidFill>
+                  <a:srgbClr val="A8B3D1"/>
+                </a:solidFill>
+                <a:latin typeface="Segoe UI"/>
+              </a:rPr>
+              <a:t>artefatos</a:t>
+            </a:r>
+            <a:r>
+              <a:rPr sz="1250" dirty="0">
+                <a:solidFill>
+                  <a:srgbClr val="A8B3D1"/>
+                </a:solidFill>
+                <a:latin typeface="Segoe UI"/>
+              </a:rPr>
+              <a:t> fake </a:t>
+            </a:r>
+            <a:r>
+              <a:rPr sz="1250" dirty="0" err="1">
+                <a:solidFill>
+                  <a:srgbClr val="A8B3D1"/>
+                </a:solidFill>
+                <a:latin typeface="Segoe UI"/>
+              </a:rPr>
+              <a:t>em</a:t>
+            </a:r>
+            <a:r>
+              <a:rPr sz="1250" dirty="0">
+                <a:solidFill>
+                  <a:srgbClr val="A8B3D1"/>
+                </a:solidFill>
+                <a:latin typeface="Segoe UI"/>
+              </a:rPr>
+              <a:t> fixtures).</a:t>
             </a:r>
           </a:p>
         </p:txBody>
@@ -8839,16 +11029,30 @@
           <a:bodyPr wrap="square" lIns="220000" tIns="200000" rIns="220000" bIns="160000" rtlCol="0" anchor="t"/>
           <a:lstStyle/>
           <a:p>
-            <a:pPr algn="ctr"/>
-            <a:r>
-              <a:rPr sz="1700" b="1">
+            <a:r>
+              <a:rPr sz="1700" b="1" dirty="0">
                 <a:solidFill>
                   <a:srgbClr val="4F9CFF"/>
                 </a:solidFill>
                 <a:latin typeface="Segoe UI"/>
               </a:rPr>
-              <a:t>Sistema funcional</a:t>
-            </a:r>
+              <a:t>Sistema </a:t>
+            </a:r>
+            <a:r>
+              <a:rPr sz="1700" b="1" dirty="0" err="1">
+                <a:solidFill>
+                  <a:srgbClr val="4F9CFF"/>
+                </a:solidFill>
+                <a:latin typeface="Segoe UI"/>
+              </a:rPr>
+              <a:t>funcional</a:t>
+            </a:r>
+            <a:endParaRPr sz="1700" b="1" dirty="0">
+              <a:solidFill>
+                <a:srgbClr val="4F9CFF"/>
+              </a:solidFill>
+              <a:latin typeface="Segoe UI"/>
+            </a:endParaRPr>
           </a:p>
           <a:p>
             <a:pPr>
@@ -8860,14 +11064,47 @@
               </a:spcBef>
             </a:pPr>
             <a:r>
-              <a:rPr sz="1250">
-                <a:solidFill>
-                  <a:srgbClr val="A8B3D1"/>
-                </a:solidFill>
-                <a:latin typeface="Segoe UI"/>
-              </a:rPr>
-              <a:t>API REST devolvendo recomendações</a:t>
-            </a:r>
+              <a:rPr sz="1250" dirty="0">
+                <a:solidFill>
+                  <a:srgbClr val="A8B3D1"/>
+                </a:solidFill>
+                <a:latin typeface="Segoe UI"/>
+              </a:rPr>
+              <a:t>API REST </a:t>
+            </a:r>
+            <a:r>
+              <a:rPr sz="1250" dirty="0" err="1">
+                <a:solidFill>
+                  <a:srgbClr val="A8B3D1"/>
+                </a:solidFill>
+                <a:latin typeface="Segoe UI"/>
+              </a:rPr>
+              <a:t>devolvendo</a:t>
+            </a:r>
+            <a:r>
+              <a:rPr sz="1250" dirty="0">
+                <a:solidFill>
+                  <a:srgbClr val="A8B3D1"/>
+                </a:solidFill>
+                <a:latin typeface="Segoe UI"/>
+              </a:rPr>
+              <a:t> </a:t>
+            </a:r>
+            <a:r>
+              <a:rPr sz="1250" dirty="0" err="1">
+                <a:solidFill>
+                  <a:srgbClr val="A8B3D1"/>
+                </a:solidFill>
+                <a:latin typeface="Segoe UI"/>
+              </a:rPr>
+              <a:t>recomendações</a:t>
+            </a:r>
+            <a:endParaRPr sz="1250" dirty="0">
+              <a:solidFill>
+                <a:srgbClr val="A8B3D1"/>
+              </a:solidFill>
+              <a:latin typeface="Segoe UI"/>
+            </a:endParaRPr>
           </a:p>
           <a:p>
             <a:pPr>
@@ -8879,13 +11116,76 @@
               </a:spcBef>
             </a:pPr>
             <a:r>
-              <a:rPr sz="1250">
-                <a:solidFill>
-                  <a:srgbClr val="A8B3D1"/>
-                </a:solidFill>
-                <a:latin typeface="Segoe UI"/>
-              </a:rPr>
-              <a:t>personalizadas por usuário em &lt; 2s.</a:t>
+              <a:rPr sz="1250" dirty="0" err="1">
+                <a:solidFill>
+                  <a:srgbClr val="A8B3D1"/>
+                </a:solidFill>
+                <a:latin typeface="Segoe UI"/>
+              </a:rPr>
+              <a:t>personalizadas</a:t>
+            </a:r>
+            <a:r>
+              <a:rPr sz="1250" dirty="0">
+                <a:solidFill>
+                  <a:srgbClr val="A8B3D1"/>
+                </a:solidFill>
+                <a:latin typeface="Segoe UI"/>
+              </a:rPr>
+              <a:t> </a:t>
+            </a:r>
+            <a:r>
+              <a:rPr sz="1250" dirty="0" err="1">
+                <a:solidFill>
+                  <a:srgbClr val="A8B3D1"/>
+                </a:solidFill>
+                <a:latin typeface="Segoe UI"/>
+              </a:rPr>
+              <a:t>por</a:t>
+            </a:r>
+            <a:r>
+              <a:rPr sz="1250" dirty="0">
+                <a:solidFill>
+                  <a:srgbClr val="A8B3D1"/>
+                </a:solidFill>
+                <a:latin typeface="Segoe UI"/>
+              </a:rPr>
+              <a:t> </a:t>
+            </a:r>
+            <a:r>
+              <a:rPr sz="1250" dirty="0" err="1">
+                <a:solidFill>
+                  <a:srgbClr val="A8B3D1"/>
+                </a:solidFill>
+                <a:latin typeface="Segoe UI"/>
+              </a:rPr>
+              <a:t>usuário</a:t>
+            </a:r>
+            <a:r>
+              <a:rPr sz="1250" dirty="0">
+                <a:solidFill>
+                  <a:srgbClr val="A8B3D1"/>
+                </a:solidFill>
+                <a:latin typeface="Segoe UI"/>
+              </a:rPr>
+              <a:t> </a:t>
+            </a:r>
+            <a:r>
+              <a:rPr sz="1250" dirty="0" err="1">
+                <a:solidFill>
+                  <a:srgbClr val="A8B3D1"/>
+                </a:solidFill>
+                <a:latin typeface="Segoe UI"/>
+              </a:rPr>
+              <a:t>em</a:t>
+            </a:r>
+            <a:r>
+              <a:rPr sz="1250" dirty="0">
+                <a:solidFill>
+                  <a:srgbClr val="A8B3D1"/>
+                </a:solidFill>
+                <a:latin typeface="Segoe UI"/>
+              </a:rPr>
+              <a:t> &lt; 2s.</a:t>
             </a:r>
           </a:p>
         </p:txBody>
@@ -8930,15 +11230,23 @@
           <a:bodyPr wrap="square" lIns="220000" tIns="200000" rIns="220000" bIns="160000" rtlCol="0" anchor="t"/>
           <a:lstStyle/>
           <a:p>
-            <a:pPr algn="ctr"/>
-            <a:r>
-              <a:rPr sz="1700" b="1">
+            <a:r>
+              <a:rPr sz="1700" b="1" dirty="0" err="1">
                 <a:solidFill>
                   <a:srgbClr val="2EE6B6"/>
                 </a:solidFill>
                 <a:latin typeface="Segoe UI"/>
               </a:rPr>
               <a:t>Avaliação</a:t>
+            </a:r>
+            <a:r>
+              <a:rPr sz="1700" b="1" dirty="0">
+                <a:solidFill>
+                  <a:srgbClr val="2EE6B6"/>
+                </a:solidFill>
+                <a:latin typeface="Segoe UI"/>
+              </a:rPr>
+              <a:t> (conjunto de teste)</a:t>
             </a:r>
           </a:p>
           <a:p>
@@ -8951,13 +11259,40 @@
               </a:spcBef>
             </a:pPr>
             <a:r>
-              <a:rPr sz="1250">
-                <a:solidFill>
-                  <a:srgbClr val="A8B3D1"/>
-                </a:solidFill>
-                <a:latin typeface="Segoe UI"/>
-              </a:rPr>
-              <a:t>Métricas de classificação:</a:t>
+              <a:rPr sz="1250" dirty="0" err="1">
+                <a:solidFill>
+                  <a:srgbClr val="A8B3D1"/>
+                </a:solidFill>
+                <a:latin typeface="Segoe UI"/>
+              </a:rPr>
+              <a:t>Acurácia</a:t>
+            </a:r>
+            <a:r>
+              <a:rPr sz="1250" dirty="0">
+                <a:solidFill>
+                  <a:srgbClr val="A8B3D1"/>
+                </a:solidFill>
+                <a:latin typeface="Segoe UI"/>
+              </a:rPr>
+              <a:t> 0.70 · </a:t>
+            </a:r>
+            <a:r>
+              <a:rPr sz="1250" dirty="0" err="1">
+                <a:solidFill>
+                  <a:srgbClr val="A8B3D1"/>
+                </a:solidFill>
+                <a:latin typeface="Segoe UI"/>
+              </a:rPr>
+              <a:t>Precisão</a:t>
+            </a:r>
+            <a:r>
+              <a:rPr sz="1250" dirty="0">
+                <a:solidFill>
+                  <a:srgbClr val="A8B3D1"/>
+                </a:solidFill>
+                <a:latin typeface="Segoe UI"/>
+              </a:rPr>
+              <a:t> 0.69</a:t>
             </a:r>
           </a:p>
           <a:p>
@@ -8970,13 +11305,13 @@
               </a:spcBef>
             </a:pPr>
             <a:r>
-              <a:rPr sz="1250">
-                <a:solidFill>
-                  <a:srgbClr val="A8B3D1"/>
-                </a:solidFill>
-                <a:latin typeface="Segoe UI"/>
-              </a:rPr>
-              <a:t>Acurácia · Precisão · Recall · F1.</a:t>
+              <a:rPr sz="1250" dirty="0">
+                <a:solidFill>
+                  <a:srgbClr val="A8B3D1"/>
+                </a:solidFill>
+                <a:latin typeface="Segoe UI"/>
+              </a:rPr>
+              <a:t>Recall 0.71 · F1 0.70</a:t>
             </a:r>
           </a:p>
         </p:txBody>
@@ -9021,9 +11356,8 @@
           <a:bodyPr wrap="square" lIns="220000" tIns="200000" rIns="220000" bIns="160000" rtlCol="0" anchor="t"/>
           <a:lstStyle/>
           <a:p>
-            <a:pPr algn="ctr"/>
-            <a:r>
-              <a:rPr sz="1700" b="1">
+            <a:r>
+              <a:rPr sz="1700" b="1" dirty="0" err="1">
                 <a:solidFill>
                   <a:srgbClr val="2EE6B6"/>
                 </a:solidFill>
@@ -9031,6 +11365,12 @@
               </a:rPr>
               <a:t>Robustez</a:t>
             </a:r>
+            <a:endParaRPr sz="1700" b="1" dirty="0">
+              <a:solidFill>
+                <a:srgbClr val="2EE6B6"/>
+              </a:solidFill>
+              <a:latin typeface="Segoe UI"/>
+            </a:endParaRPr>
           </a:p>
           <a:p>
             <a:pPr>
@@ -9042,13 +11382,49 @@
               </a:spcBef>
             </a:pPr>
             <a:r>
-              <a:rPr sz="1250">
-                <a:solidFill>
-                  <a:srgbClr val="A8B3D1"/>
-                </a:solidFill>
-                <a:latin typeface="Segoe UI"/>
-              </a:rPr>
-              <a:t>Fallback por popularidade +</a:t>
+              <a:rPr sz="1250" dirty="0">
+                <a:solidFill>
+                  <a:srgbClr val="A8B3D1"/>
+                </a:solidFill>
+                <a:latin typeface="Segoe UI"/>
+              </a:rPr>
+              <a:t>Fallback </a:t>
+            </a:r>
+            <a:r>
+              <a:rPr sz="1250" dirty="0" err="1">
+                <a:solidFill>
+                  <a:srgbClr val="A8B3D1"/>
+                </a:solidFill>
+                <a:latin typeface="Segoe UI"/>
+              </a:rPr>
+              <a:t>por</a:t>
+            </a:r>
+            <a:r>
+              <a:rPr sz="1250" dirty="0">
+                <a:solidFill>
+                  <a:srgbClr val="A8B3D1"/>
+                </a:solidFill>
+                <a:latin typeface="Segoe UI"/>
+              </a:rPr>
+              <a:t> </a:t>
+            </a:r>
+            <a:r>
+              <a:rPr sz="1250" dirty="0" err="1">
+                <a:solidFill>
+                  <a:srgbClr val="A8B3D1"/>
+                </a:solidFill>
+                <a:latin typeface="Segoe UI"/>
+              </a:rPr>
+              <a:t>popularidade</a:t>
+            </a:r>
+            <a:r>
+              <a:rPr sz="1250" dirty="0">
+                <a:solidFill>
+                  <a:srgbClr val="A8B3D1"/>
+                </a:solidFill>
+                <a:latin typeface="Segoe UI"/>
+              </a:rPr>
+              <a:t> +</a:t>
             </a:r>
           </a:p>
           <a:p>
@@ -9061,13 +11437,31 @@
               </a:spcBef>
             </a:pPr>
             <a:r>
-              <a:rPr sz="1250">
-                <a:solidFill>
-                  <a:srgbClr val="A8B3D1"/>
-                </a:solidFill>
-                <a:latin typeface="Segoe UI"/>
-              </a:rPr>
-              <a:t>143 testes automatizados.</a:t>
+              <a:rPr sz="1250" dirty="0">
+                <a:solidFill>
+                  <a:srgbClr val="A8B3D1"/>
+                </a:solidFill>
+                <a:latin typeface="Segoe UI"/>
+              </a:rPr>
+              <a:t>143 testes </a:t>
+            </a:r>
+            <a:r>
+              <a:rPr sz="1250" dirty="0" err="1">
+                <a:solidFill>
+                  <a:srgbClr val="A8B3D1"/>
+                </a:solidFill>
+                <a:latin typeface="Segoe UI"/>
+              </a:rPr>
+              <a:t>automatizados</a:t>
+            </a:r>
+            <a:r>
+              <a:rPr sz="1250" dirty="0">
+                <a:solidFill>
+                  <a:srgbClr val="A8B3D1"/>
+                </a:solidFill>
+                <a:latin typeface="Segoe UI"/>
+              </a:rPr>
+              <a:t>.</a:t>
             </a:r>
           </a:p>
         </p:txBody>
@@ -9112,9 +11506,8 @@
           <a:bodyPr wrap="square" lIns="220000" tIns="200000" rIns="220000" bIns="160000" rtlCol="0" anchor="t"/>
           <a:lstStyle/>
           <a:p>
-            <a:pPr algn="ctr"/>
-            <a:r>
-              <a:rPr sz="1700" b="1">
+            <a:r>
+              <a:rPr sz="1700" b="1" dirty="0" err="1">
                 <a:solidFill>
                   <a:srgbClr val="4F9CFF"/>
                 </a:solidFill>
@@ -9122,6 +11515,12 @@
               </a:rPr>
               <a:t>Reprodutibilidade</a:t>
             </a:r>
+            <a:endParaRPr sz="1700" b="1" dirty="0">
+              <a:solidFill>
+                <a:srgbClr val="4F9CFF"/>
+              </a:solidFill>
+              <a:latin typeface="Segoe UI"/>
+            </a:endParaRPr>
           </a:p>
           <a:p>
             <a:pPr>
@@ -9133,14 +11532,47 @@
               </a:spcBef>
             </a:pPr>
             <a:r>
-              <a:rPr sz="1250">
-                <a:solidFill>
-                  <a:srgbClr val="A8B3D1"/>
-                </a:solidFill>
-                <a:latin typeface="Segoe UI"/>
-              </a:rPr>
-              <a:t>Pipeline DVC + rastreio MLflow</a:t>
-            </a:r>
+              <a:rPr sz="1250" dirty="0">
+                <a:solidFill>
+                  <a:srgbClr val="A8B3D1"/>
+                </a:solidFill>
+                <a:latin typeface="Segoe UI"/>
+              </a:rPr>
+              <a:t>Pipeline DVC + </a:t>
+            </a:r>
+            <a:r>
+              <a:rPr sz="1250" dirty="0" err="1">
+                <a:solidFill>
+                  <a:srgbClr val="A8B3D1"/>
+                </a:solidFill>
+                <a:latin typeface="Segoe UI"/>
+              </a:rPr>
+              <a:t>rastreio</a:t>
+            </a:r>
+            <a:r>
+              <a:rPr sz="1250" dirty="0">
+                <a:solidFill>
+                  <a:srgbClr val="A8B3D1"/>
+                </a:solidFill>
+                <a:latin typeface="Segoe UI"/>
+              </a:rPr>
+              <a:t> </a:t>
+            </a:r>
+            <a:r>
+              <a:rPr sz="1250" dirty="0" err="1">
+                <a:solidFill>
+                  <a:srgbClr val="A8B3D1"/>
+                </a:solidFill>
+                <a:latin typeface="Segoe UI"/>
+              </a:rPr>
+              <a:t>MLflow</a:t>
+            </a:r>
+            <a:endParaRPr sz="1250" dirty="0">
+              <a:solidFill>
+                <a:srgbClr val="A8B3D1"/>
+              </a:solidFill>
+              <a:latin typeface="Segoe UI"/>
+            </a:endParaRPr>
           </a:p>
           <a:p>
             <a:pPr>
@@ -9152,13 +11584,67 @@
               </a:spcBef>
             </a:pPr>
             <a:r>
-              <a:rPr sz="1250">
-                <a:solidFill>
-                  <a:srgbClr val="A8B3D1"/>
-                </a:solidFill>
-                <a:latin typeface="Segoe UI"/>
-              </a:rPr>
-              <a:t>→ qualquer experimento reproduzível.</a:t>
+              <a:rPr sz="1250" dirty="0">
+                <a:solidFill>
+                  <a:srgbClr val="A8B3D1"/>
+                </a:solidFill>
+                <a:latin typeface="Segoe UI"/>
+              </a:rPr>
+              <a:t>→ </a:t>
+            </a:r>
+            <a:r>
+              <a:rPr sz="1250" dirty="0" err="1">
+                <a:solidFill>
+                  <a:srgbClr val="A8B3D1"/>
+                </a:solidFill>
+                <a:latin typeface="Segoe UI"/>
+              </a:rPr>
+              <a:t>qualquer</a:t>
+            </a:r>
+            <a:r>
+              <a:rPr sz="1250" dirty="0">
+                <a:solidFill>
+                  <a:srgbClr val="A8B3D1"/>
+                </a:solidFill>
+                <a:latin typeface="Segoe UI"/>
+              </a:rPr>
+              <a:t> </a:t>
+            </a:r>
+            <a:r>
+              <a:rPr sz="1250" dirty="0" err="1">
+                <a:solidFill>
+                  <a:srgbClr val="A8B3D1"/>
+                </a:solidFill>
+                <a:latin typeface="Segoe UI"/>
+              </a:rPr>
+              <a:t>experimento</a:t>
+            </a:r>
+            <a:r>
+              <a:rPr sz="1250" dirty="0">
+                <a:solidFill>
+                  <a:srgbClr val="A8B3D1"/>
+                </a:solidFill>
+                <a:latin typeface="Segoe UI"/>
+              </a:rPr>
+              <a:t> </a:t>
+            </a:r>
+            <a:r>
+              <a:rPr sz="1250" dirty="0" err="1">
+                <a:solidFill>
+                  <a:srgbClr val="A8B3D1"/>
+                </a:solidFill>
+                <a:latin typeface="Segoe UI"/>
+              </a:rPr>
+              <a:t>reproduzível</a:t>
+            </a:r>
+            <a:r>
+              <a:rPr sz="1250" dirty="0">
+                <a:solidFill>
+                  <a:srgbClr val="A8B3D1"/>
+                </a:solidFill>
+                <a:latin typeface="Segoe UI"/>
+              </a:rPr>
+              <a:t>.</a:t>
             </a:r>
           </a:p>
         </p:txBody>

</xml_diff>